<commit_message>
finished poster draft + updated hours
</commit_message>
<xml_diff>
--- a/AT/I-Cat Poster.pptx
+++ b/AT/I-Cat Poster.pptx
@@ -4125,25 +4125,8 @@
                 <a:latin typeface="Arial" panose="020B0604020202020204" pitchFamily="34" charset="0"/>
                 <a:cs typeface="Arial" panose="020B0604020202020204" pitchFamily="34" charset="0"/>
               </a:rPr>
-              <a:t>Indexed Concatenation (I-Cat): A Method for Representing and Operating on Repeating </a:t>
-            </a:r>
-            <a:r>
-              <a:rPr lang="en-US" sz="6600" b="1" dirty="0" err="1">
-                <a:solidFill>
-                  <a:schemeClr val="bg1"/>
-                </a:solidFill>
-                <a:latin typeface="Arial" panose="020B0604020202020204" pitchFamily="34" charset="0"/>
-                <a:cs typeface="Arial" panose="020B0604020202020204" pitchFamily="34" charset="0"/>
-              </a:rPr>
-              <a:t>Numerics</a:t>
-            </a:r>
-            <a:endParaRPr lang="en-US" sz="6600" b="1" dirty="0">
-              <a:solidFill>
-                <a:schemeClr val="bg1"/>
-              </a:solidFill>
-              <a:latin typeface="Arial" panose="020B0604020202020204" pitchFamily="34" charset="0"/>
-              <a:cs typeface="Arial" panose="020B0604020202020204" pitchFamily="34" charset="0"/>
-            </a:endParaRPr>
+              <a:t>Indexed Concatenation (I-Cat): A Method for Representing and Operating on Repeating Numbers</a:t>
+            </a:r>
           </a:p>
         </p:txBody>
       </p:sp>
@@ -4986,7 +4969,7 @@
         <p:spPr bwMode="auto">
           <a:xfrm>
             <a:off x="24879397" y="15046515"/>
-            <a:ext cx="7268693" cy="381629"/>
+            <a:ext cx="7268693" cy="1520416"/>
           </a:xfrm>
           <a:prstGeom prst="rect">
             <a:avLst/>
@@ -5004,7 +4987,7 @@
           </a:ln>
         </p:spPr>
         <p:txBody>
-          <a:bodyPr wrap="square" lIns="60945" tIns="30473" rIns="60945" bIns="30473">
+          <a:bodyPr wrap="square" lIns="91440" tIns="91440" rIns="91440" bIns="91440">
             <a:spAutoFit/>
           </a:bodyPr>
           <a:lstStyle>
@@ -5118,10 +5101,12 @@
             </a:lvl9pPr>
           </a:lstStyle>
           <a:p>
-            <a:pPr algn="just">
+            <a:pPr marL="342900" indent="-342900" algn="just">
               <a:lnSpc>
                 <a:spcPct val="110000"/>
               </a:lnSpc>
+              <a:buFont typeface="Arial" panose="020B0604020202020204" pitchFamily="34" charset="0"/>
+              <a:buChar char="•"/>
             </a:pPr>
             <a:r>
               <a:rPr lang="en-US" dirty="0">
@@ -5129,7 +5114,58 @@
                 <a:ea typeface="Open Sans" panose="020B0606030504020204" pitchFamily="34" charset="0"/>
                 <a:cs typeface="Open Sans" panose="020B0606030504020204" pitchFamily="34" charset="0"/>
               </a:rPr>
-              <a:t>Add your information, graphs and images to this section.</a:t>
+              <a:t>More complex operations</a:t>
+            </a:r>
+          </a:p>
+          <a:p>
+            <a:pPr marL="342900" indent="-342900" algn="just">
+              <a:lnSpc>
+                <a:spcPct val="110000"/>
+              </a:lnSpc>
+              <a:buFont typeface="Arial" panose="020B0604020202020204" pitchFamily="34" charset="0"/>
+              <a:buChar char="•"/>
+            </a:pPr>
+            <a:r>
+              <a:rPr lang="en-US" dirty="0">
+                <a:latin typeface="Open Sans" panose="020B0606030504020204" pitchFamily="34" charset="0"/>
+                <a:ea typeface="Open Sans" panose="020B0606030504020204" pitchFamily="34" charset="0"/>
+                <a:cs typeface="Open Sans" panose="020B0606030504020204" pitchFamily="34" charset="0"/>
+              </a:rPr>
+              <a:t>Computational applications</a:t>
+            </a:r>
+          </a:p>
+          <a:p>
+            <a:pPr marL="342900" indent="-342900" algn="just">
+              <a:lnSpc>
+                <a:spcPct val="110000"/>
+              </a:lnSpc>
+              <a:buFont typeface="Arial" panose="020B0604020202020204" pitchFamily="34" charset="0"/>
+              <a:buChar char="•"/>
+            </a:pPr>
+            <a:r>
+              <a:rPr lang="en-US" dirty="0">
+                <a:latin typeface="Open Sans" panose="020B0606030504020204" pitchFamily="34" charset="0"/>
+                <a:ea typeface="Open Sans" panose="020B0606030504020204" pitchFamily="34" charset="0"/>
+                <a:cs typeface="Open Sans" panose="020B0606030504020204" pitchFamily="34" charset="0"/>
+              </a:rPr>
+              <a:t>Develop more efficient algorithms</a:t>
+            </a:r>
+          </a:p>
+          <a:p>
+            <a:pPr marL="342900" indent="-342900" algn="just">
+              <a:lnSpc>
+                <a:spcPct val="110000"/>
+              </a:lnSpc>
+              <a:buFont typeface="Arial" panose="020B0604020202020204" pitchFamily="34" charset="0"/>
+              <a:buChar char="•"/>
+            </a:pPr>
+            <a:r>
+              <a:rPr lang="en-US" dirty="0">
+                <a:latin typeface="Open Sans" panose="020B0606030504020204" pitchFamily="34" charset="0"/>
+                <a:ea typeface="Open Sans" panose="020B0606030504020204" pitchFamily="34" charset="0"/>
+                <a:cs typeface="Open Sans" panose="020B0606030504020204" pitchFamily="34" charset="0"/>
+              </a:rPr>
+              <a:t>Continue analyzing patterns</a:t>
             </a:r>
           </a:p>
         </p:txBody>
@@ -5205,7 +5241,7 @@
         <p:spPr bwMode="auto">
           <a:xfrm>
             <a:off x="24879397" y="19105121"/>
-            <a:ext cx="7268693" cy="381629"/>
+            <a:ext cx="7268693" cy="843308"/>
           </a:xfrm>
           <a:prstGeom prst="rect">
             <a:avLst/>
@@ -5223,7 +5259,7 @@
           </a:ln>
         </p:spPr>
         <p:txBody>
-          <a:bodyPr wrap="square" lIns="60945" tIns="30473" rIns="60945" bIns="30473">
+          <a:bodyPr wrap="square" lIns="91440" tIns="91440" rIns="91440" bIns="91440">
             <a:spAutoFit/>
           </a:bodyPr>
           <a:lstStyle>
@@ -5348,7 +5384,7 @@
                 <a:ea typeface="Open Sans" panose="020B0606030504020204" pitchFamily="34" charset="0"/>
                 <a:cs typeface="Open Sans" panose="020B0606030504020204" pitchFamily="34" charset="0"/>
               </a:rPr>
-              <a:t>Add your information, graphs and images to this section.</a:t>
+              <a:t>Special thanks to Dr. Kenneth Caviness for his guidance and support.</a:t>
             </a:r>
           </a:p>
         </p:txBody>
@@ -5424,7 +5460,7 @@
         <p:spPr bwMode="auto">
           <a:xfrm>
             <a:off x="24879397" y="5572470"/>
-            <a:ext cx="7268693" cy="381629"/>
+            <a:ext cx="7268693" cy="1181862"/>
           </a:xfrm>
           <a:prstGeom prst="rect">
             <a:avLst/>
@@ -5442,7 +5478,7 @@
           </a:ln>
         </p:spPr>
         <p:txBody>
-          <a:bodyPr wrap="square" lIns="60945" tIns="30473" rIns="60945" bIns="30473">
+          <a:bodyPr wrap="square" lIns="91440" tIns="91440" rIns="91440" bIns="91440">
             <a:spAutoFit/>
           </a:bodyPr>
           <a:lstStyle>
@@ -5556,10 +5592,12 @@
             </a:lvl9pPr>
           </a:lstStyle>
           <a:p>
-            <a:pPr algn="just">
+            <a:pPr marL="342900" indent="-342900" algn="just">
               <a:lnSpc>
                 <a:spcPct val="110000"/>
               </a:lnSpc>
+              <a:buFont typeface="Arial" panose="020B0604020202020204" pitchFamily="34" charset="0"/>
+              <a:buChar char="•"/>
             </a:pPr>
             <a:r>
               <a:rPr lang="en-US" dirty="0">
@@ -5567,7 +5605,41 @@
                 <a:ea typeface="Open Sans" panose="020B0606030504020204" pitchFamily="34" charset="0"/>
                 <a:cs typeface="Open Sans" panose="020B0606030504020204" pitchFamily="34" charset="0"/>
               </a:rPr>
-              <a:t>Add your information, graphs and images to this section.</a:t>
+              <a:t>Compact representation of repeating patterns.</a:t>
+            </a:r>
+          </a:p>
+          <a:p>
+            <a:pPr marL="342900" indent="-342900" algn="just">
+              <a:lnSpc>
+                <a:spcPct val="110000"/>
+              </a:lnSpc>
+              <a:buFont typeface="Arial" panose="020B0604020202020204" pitchFamily="34" charset="0"/>
+              <a:buChar char="•"/>
+            </a:pPr>
+            <a:r>
+              <a:rPr lang="en-US" dirty="0">
+                <a:latin typeface="Open Sans" panose="020B0606030504020204" pitchFamily="34" charset="0"/>
+                <a:ea typeface="Open Sans" panose="020B0606030504020204" pitchFamily="34" charset="0"/>
+                <a:cs typeface="Open Sans" panose="020B0606030504020204" pitchFamily="34" charset="0"/>
+              </a:rPr>
+              <a:t>Simplifies operations with infinite decimals.</a:t>
+            </a:r>
+          </a:p>
+          <a:p>
+            <a:pPr marL="342900" indent="-342900" algn="just">
+              <a:lnSpc>
+                <a:spcPct val="110000"/>
+              </a:lnSpc>
+              <a:buFont typeface="Arial" panose="020B0604020202020204" pitchFamily="34" charset="0"/>
+              <a:buChar char="•"/>
+            </a:pPr>
+            <a:r>
+              <a:rPr lang="en-US" dirty="0">
+                <a:latin typeface="Open Sans" panose="020B0606030504020204" pitchFamily="34" charset="0"/>
+                <a:ea typeface="Open Sans" panose="020B0606030504020204" pitchFamily="34" charset="0"/>
+                <a:cs typeface="Open Sans" panose="020B0606030504020204" pitchFamily="34" charset="0"/>
+              </a:rPr>
+              <a:t>Useful in mathematical and computational contexts.</a:t>
             </a:r>
           </a:p>
         </p:txBody>
@@ -5643,7 +5715,7 @@
         <p:spPr bwMode="auto">
           <a:xfrm>
             <a:off x="24879397" y="11725353"/>
-            <a:ext cx="7268693" cy="381629"/>
+            <a:ext cx="7268693" cy="1181862"/>
           </a:xfrm>
           <a:prstGeom prst="rect">
             <a:avLst/>
@@ -5661,7 +5733,7 @@
           </a:ln>
         </p:spPr>
         <p:txBody>
-          <a:bodyPr wrap="square" lIns="60945" tIns="30473" rIns="60945" bIns="30473">
+          <a:bodyPr wrap="square" lIns="91440" tIns="91440" rIns="91440" bIns="91440">
             <a:spAutoFit/>
           </a:bodyPr>
           <a:lstStyle>
@@ -5775,18 +5847,37 @@
             </a:lvl9pPr>
           </a:lstStyle>
           <a:p>
-            <a:pPr algn="just">
+            <a:pPr marL="342900" indent="-342900" algn="just">
               <a:lnSpc>
                 <a:spcPct val="110000"/>
               </a:lnSpc>
-            </a:pPr>
-            <a:r>
-              <a:rPr lang="en-US">
+              <a:buFont typeface="Arial" panose="020B0604020202020204" pitchFamily="34" charset="0"/>
+              <a:buChar char="•"/>
+            </a:pPr>
+            <a:r>
+              <a:rPr lang="en-US" dirty="0">
                 <a:latin typeface="Open Sans" panose="020B0606030504020204" pitchFamily="34" charset="0"/>
                 <a:ea typeface="Open Sans" panose="020B0606030504020204" pitchFamily="34" charset="0"/>
                 <a:cs typeface="Open Sans" panose="020B0606030504020204" pitchFamily="34" charset="0"/>
               </a:rPr>
-              <a:t>Add your information, graphs and images to this section.</a:t>
+              <a:t>I-Cat notation provides a structured way to represent and work with repeating numbers. </a:t>
+            </a:r>
+          </a:p>
+          <a:p>
+            <a:pPr marL="342900" indent="-342900" algn="just">
+              <a:lnSpc>
+                <a:spcPct val="110000"/>
+              </a:lnSpc>
+              <a:buFont typeface="Arial" panose="020B0604020202020204" pitchFamily="34" charset="0"/>
+              <a:buChar char="•"/>
+            </a:pPr>
+            <a:r>
+              <a:rPr lang="en-US" dirty="0">
+                <a:latin typeface="Open Sans" panose="020B0606030504020204" pitchFamily="34" charset="0"/>
+                <a:ea typeface="Open Sans" panose="020B0606030504020204" pitchFamily="34" charset="0"/>
+                <a:cs typeface="Open Sans" panose="020B0606030504020204" pitchFamily="34" charset="0"/>
+              </a:rPr>
+              <a:t>It simplifies both representation and operations.</a:t>
             </a:r>
           </a:p>
         </p:txBody>

</xml_diff>

<commit_message>
updated examples + poster
</commit_message>
<xml_diff>
--- a/AT/I-Cat Poster.pptx
+++ b/AT/I-Cat Poster.pptx
@@ -4407,7 +4407,7 @@
         </p:nvSpPr>
         <p:spPr bwMode="auto">
           <a:xfrm>
-            <a:off x="768353" y="5573219"/>
+            <a:off x="768353" y="5572470"/>
             <a:ext cx="7268693" cy="3213187"/>
           </a:xfrm>
           <a:prstGeom prst="rect">
@@ -4625,7 +4625,7 @@
         </p:nvSpPr>
         <p:spPr bwMode="auto">
           <a:xfrm>
-            <a:off x="768353" y="4755724"/>
+            <a:off x="768353" y="4755723"/>
             <a:ext cx="7268693" cy="582201"/>
           </a:xfrm>
           <a:prstGeom prst="rect">
@@ -4968,7 +4968,7 @@
         </p:nvSpPr>
         <p:spPr bwMode="auto">
           <a:xfrm>
-            <a:off x="24879397" y="15046515"/>
+            <a:off x="24879396" y="17030644"/>
             <a:ext cx="7268693" cy="1520416"/>
           </a:xfrm>
           <a:prstGeom prst="rect">
@@ -5186,7 +5186,7 @@
         </p:nvSpPr>
         <p:spPr bwMode="auto">
           <a:xfrm>
-            <a:off x="24879397" y="14229394"/>
+            <a:off x="24879396" y="16213523"/>
             <a:ext cx="7268693" cy="582201"/>
           </a:xfrm>
           <a:prstGeom prst="rect">
@@ -5240,7 +5240,7 @@
         </p:nvSpPr>
         <p:spPr bwMode="auto">
           <a:xfrm>
-            <a:off x="24879397" y="19105121"/>
+            <a:off x="24879397" y="19577128"/>
             <a:ext cx="7268693" cy="843308"/>
           </a:xfrm>
           <a:prstGeom prst="rect">
@@ -5405,7 +5405,7 @@
         </p:nvSpPr>
         <p:spPr bwMode="auto">
           <a:xfrm>
-            <a:off x="24879397" y="18288000"/>
+            <a:off x="24879396" y="18812720"/>
             <a:ext cx="7268693" cy="582201"/>
           </a:xfrm>
           <a:prstGeom prst="rect">
@@ -5459,7 +5459,7 @@
         </p:nvSpPr>
         <p:spPr bwMode="auto">
           <a:xfrm>
-            <a:off x="24879397" y="5572470"/>
+            <a:off x="24878694" y="12557868"/>
             <a:ext cx="7268693" cy="1181862"/>
           </a:xfrm>
           <a:prstGeom prst="rect">
@@ -5660,7 +5660,7 @@
         </p:nvSpPr>
         <p:spPr bwMode="auto">
           <a:xfrm>
-            <a:off x="24879397" y="4755724"/>
+            <a:off x="24878694" y="11741121"/>
             <a:ext cx="7268693" cy="582201"/>
           </a:xfrm>
           <a:prstGeom prst="rect">
@@ -5714,7 +5714,7 @@
         </p:nvSpPr>
         <p:spPr bwMode="auto">
           <a:xfrm>
-            <a:off x="24879397" y="11725353"/>
+            <a:off x="24878694" y="14796741"/>
             <a:ext cx="7268693" cy="1181862"/>
           </a:xfrm>
           <a:prstGeom prst="rect">
@@ -5898,7 +5898,7 @@
         </p:nvSpPr>
         <p:spPr bwMode="auto">
           <a:xfrm>
-            <a:off x="24879397" y="10908231"/>
+            <a:off x="24878694" y="13979619"/>
             <a:ext cx="7268693" cy="582201"/>
           </a:xfrm>
           <a:prstGeom prst="rect">
@@ -6261,44 +6261,8 @@
         </p:blipFill>
         <p:spPr>
           <a:xfrm>
-            <a:off x="2948548" y="14553741"/>
+            <a:off x="2948549" y="14553741"/>
             <a:ext cx="2908300" cy="596900"/>
-          </a:xfrm>
-          <a:prstGeom prst="rect">
-            <a:avLst/>
-          </a:prstGeom>
-        </p:spPr>
-      </p:pic>
-      <p:pic>
-        <p:nvPicPr>
-          <p:cNvPr id="9" name="Picture 8">
-            <a:extLst>
-              <a:ext uri="{FF2B5EF4-FFF2-40B4-BE49-F238E27FC236}">
-                <a16:creationId xmlns:a16="http://schemas.microsoft.com/office/drawing/2014/main" id="{9C6AEC37-019C-7034-D507-EEF10D28ADDE}"/>
-              </a:ext>
-            </a:extLst>
-          </p:cNvPr>
-          <p:cNvPicPr>
-            <a:picLocks noChangeAspect="1"/>
-          </p:cNvPicPr>
-          <p:nvPr/>
-        </p:nvPicPr>
-        <p:blipFill>
-          <a:blip r:embed="rId4">
-            <a:extLst>
-              <a:ext uri="{28A0092B-C50C-407E-A947-70E740481C1C}">
-                <a14:useLocalDpi xmlns:a14="http://schemas.microsoft.com/office/drawing/2010/main" val="0"/>
-              </a:ext>
-            </a:extLst>
-          </a:blip>
-          <a:stretch>
-            <a:fillRect/>
-          </a:stretch>
-        </p:blipFill>
-        <p:spPr>
-          <a:xfrm>
-            <a:off x="2719948" y="15299196"/>
-            <a:ext cx="3365500" cy="596900"/>
           </a:xfrm>
           <a:prstGeom prst="rect">
             <a:avLst/>
@@ -6566,78 +6530,6 @@
           </a:p>
         </p:txBody>
       </p:sp>
-      <p:pic>
-        <p:nvPicPr>
-          <p:cNvPr id="13" name="Picture 12">
-            <a:extLst>
-              <a:ext uri="{FF2B5EF4-FFF2-40B4-BE49-F238E27FC236}">
-                <a16:creationId xmlns:a16="http://schemas.microsoft.com/office/drawing/2014/main" id="{12F8B1EC-1F19-1280-A6BD-79B40F2F1F49}"/>
-              </a:ext>
-            </a:extLst>
-          </p:cNvPr>
-          <p:cNvPicPr>
-            <a:picLocks noChangeAspect="1"/>
-          </p:cNvPicPr>
-          <p:nvPr/>
-        </p:nvPicPr>
-        <p:blipFill>
-          <a:blip r:embed="rId5">
-            <a:extLst>
-              <a:ext uri="{28A0092B-C50C-407E-A947-70E740481C1C}">
-                <a14:useLocalDpi xmlns:a14="http://schemas.microsoft.com/office/drawing/2010/main" val="0"/>
-              </a:ext>
-            </a:extLst>
-          </a:blip>
-          <a:stretch>
-            <a:fillRect/>
-          </a:stretch>
-        </p:blipFill>
-        <p:spPr>
-          <a:xfrm>
-            <a:off x="2300848" y="16044651"/>
-            <a:ext cx="4203700" cy="660400"/>
-          </a:xfrm>
-          <a:prstGeom prst="rect">
-            <a:avLst/>
-          </a:prstGeom>
-        </p:spPr>
-      </p:pic>
-      <p:pic>
-        <p:nvPicPr>
-          <p:cNvPr id="15" name="Picture 14">
-            <a:extLst>
-              <a:ext uri="{FF2B5EF4-FFF2-40B4-BE49-F238E27FC236}">
-                <a16:creationId xmlns:a16="http://schemas.microsoft.com/office/drawing/2014/main" id="{B98414B0-57E3-D877-E836-3BA345A694D8}"/>
-              </a:ext>
-            </a:extLst>
-          </p:cNvPr>
-          <p:cNvPicPr>
-            <a:picLocks noChangeAspect="1"/>
-          </p:cNvPicPr>
-          <p:nvPr/>
-        </p:nvPicPr>
-        <p:blipFill>
-          <a:blip r:embed="rId6">
-            <a:extLst>
-              <a:ext uri="{28A0092B-C50C-407E-A947-70E740481C1C}">
-                <a14:useLocalDpi xmlns:a14="http://schemas.microsoft.com/office/drawing/2010/main" val="0"/>
-              </a:ext>
-            </a:extLst>
-          </a:blip>
-          <a:stretch>
-            <a:fillRect/>
-          </a:stretch>
-        </p:blipFill>
-        <p:spPr>
-          <a:xfrm>
-            <a:off x="2719949" y="17847520"/>
-            <a:ext cx="3365500" cy="1930400"/>
-          </a:xfrm>
-          <a:prstGeom prst="rect">
-            <a:avLst/>
-          </a:prstGeom>
-        </p:spPr>
-      </p:pic>
       <p:sp>
         <p:nvSpPr>
           <p:cNvPr id="32" name="TextBox 31">
@@ -6654,8 +6546,8 @@
         </p:nvSpPr>
         <p:spPr bwMode="auto">
           <a:xfrm>
-            <a:off x="8792147" y="5570974"/>
-            <a:ext cx="7268693" cy="9309408"/>
+            <a:off x="16198381" y="5572470"/>
+            <a:ext cx="8185619" cy="14726275"/>
           </a:xfrm>
           <a:prstGeom prst="rect">
             <a:avLst/>
@@ -7123,6 +7015,198 @@
               <a:cs typeface="Open Sans" panose="020B0606030504020204" pitchFamily="34" charset="0"/>
             </a:endParaRPr>
           </a:p>
+          <a:p>
+            <a:pPr algn="ctr">
+              <a:lnSpc>
+                <a:spcPct val="110000"/>
+              </a:lnSpc>
+            </a:pPr>
+            <a:endParaRPr lang="en-US" i="1" dirty="0">
+              <a:latin typeface="Cambria Math" panose="02040503050406030204" pitchFamily="18" charset="0"/>
+              <a:ea typeface="Open Sans" panose="020B0606030504020204" pitchFamily="34" charset="0"/>
+              <a:cs typeface="Open Sans" panose="020B0606030504020204" pitchFamily="34" charset="0"/>
+            </a:endParaRPr>
+          </a:p>
+          <a:p>
+            <a:pPr algn="ctr">
+              <a:lnSpc>
+                <a:spcPct val="110000"/>
+              </a:lnSpc>
+            </a:pPr>
+            <a:endParaRPr lang="en-US" b="0" i="1" dirty="0">
+              <a:latin typeface="Cambria Math" panose="02040503050406030204" pitchFamily="18" charset="0"/>
+              <a:ea typeface="Open Sans" panose="020B0606030504020204" pitchFamily="34" charset="0"/>
+              <a:cs typeface="Open Sans" panose="020B0606030504020204" pitchFamily="34" charset="0"/>
+            </a:endParaRPr>
+          </a:p>
+          <a:p>
+            <a:pPr algn="ctr">
+              <a:lnSpc>
+                <a:spcPct val="110000"/>
+              </a:lnSpc>
+            </a:pPr>
+            <a:endParaRPr lang="en-US" i="1" dirty="0">
+              <a:latin typeface="Cambria Math" panose="02040503050406030204" pitchFamily="18" charset="0"/>
+              <a:ea typeface="Open Sans" panose="020B0606030504020204" pitchFamily="34" charset="0"/>
+              <a:cs typeface="Open Sans" panose="020B0606030504020204" pitchFamily="34" charset="0"/>
+            </a:endParaRPr>
+          </a:p>
+          <a:p>
+            <a:pPr algn="ctr">
+              <a:lnSpc>
+                <a:spcPct val="110000"/>
+              </a:lnSpc>
+            </a:pPr>
+            <a:endParaRPr lang="en-US" b="0" i="1" dirty="0">
+              <a:latin typeface="Cambria Math" panose="02040503050406030204" pitchFamily="18" charset="0"/>
+              <a:ea typeface="Open Sans" panose="020B0606030504020204" pitchFamily="34" charset="0"/>
+              <a:cs typeface="Open Sans" panose="020B0606030504020204" pitchFamily="34" charset="0"/>
+            </a:endParaRPr>
+          </a:p>
+          <a:p>
+            <a:pPr algn="ctr">
+              <a:lnSpc>
+                <a:spcPct val="110000"/>
+              </a:lnSpc>
+            </a:pPr>
+            <a:endParaRPr lang="en-US" i="1" dirty="0">
+              <a:latin typeface="Cambria Math" panose="02040503050406030204" pitchFamily="18" charset="0"/>
+              <a:ea typeface="Open Sans" panose="020B0606030504020204" pitchFamily="34" charset="0"/>
+              <a:cs typeface="Open Sans" panose="020B0606030504020204" pitchFamily="34" charset="0"/>
+            </a:endParaRPr>
+          </a:p>
+          <a:p>
+            <a:pPr algn="ctr">
+              <a:lnSpc>
+                <a:spcPct val="110000"/>
+              </a:lnSpc>
+            </a:pPr>
+            <a:endParaRPr lang="en-US" b="0" i="1" dirty="0">
+              <a:latin typeface="Cambria Math" panose="02040503050406030204" pitchFamily="18" charset="0"/>
+              <a:ea typeface="Open Sans" panose="020B0606030504020204" pitchFamily="34" charset="0"/>
+              <a:cs typeface="Open Sans" panose="020B0606030504020204" pitchFamily="34" charset="0"/>
+            </a:endParaRPr>
+          </a:p>
+          <a:p>
+            <a:pPr algn="ctr">
+              <a:lnSpc>
+                <a:spcPct val="110000"/>
+              </a:lnSpc>
+            </a:pPr>
+            <a:endParaRPr lang="en-US" i="1" dirty="0">
+              <a:latin typeface="Cambria Math" panose="02040503050406030204" pitchFamily="18" charset="0"/>
+              <a:ea typeface="Open Sans" panose="020B0606030504020204" pitchFamily="34" charset="0"/>
+              <a:cs typeface="Open Sans" panose="020B0606030504020204" pitchFamily="34" charset="0"/>
+            </a:endParaRPr>
+          </a:p>
+          <a:p>
+            <a:pPr algn="ctr">
+              <a:lnSpc>
+                <a:spcPct val="110000"/>
+              </a:lnSpc>
+            </a:pPr>
+            <a:endParaRPr lang="en-US" b="0" i="1" dirty="0">
+              <a:latin typeface="Cambria Math" panose="02040503050406030204" pitchFamily="18" charset="0"/>
+              <a:ea typeface="Open Sans" panose="020B0606030504020204" pitchFamily="34" charset="0"/>
+              <a:cs typeface="Open Sans" panose="020B0606030504020204" pitchFamily="34" charset="0"/>
+            </a:endParaRPr>
+          </a:p>
+          <a:p>
+            <a:pPr algn="ctr">
+              <a:lnSpc>
+                <a:spcPct val="110000"/>
+              </a:lnSpc>
+            </a:pPr>
+            <a:endParaRPr lang="en-US" i="1" dirty="0">
+              <a:latin typeface="Cambria Math" panose="02040503050406030204" pitchFamily="18" charset="0"/>
+              <a:ea typeface="Open Sans" panose="020B0606030504020204" pitchFamily="34" charset="0"/>
+              <a:cs typeface="Open Sans" panose="020B0606030504020204" pitchFamily="34" charset="0"/>
+            </a:endParaRPr>
+          </a:p>
+          <a:p>
+            <a:pPr algn="ctr">
+              <a:lnSpc>
+                <a:spcPct val="110000"/>
+              </a:lnSpc>
+            </a:pPr>
+            <a:endParaRPr lang="en-US" b="0" i="1" dirty="0">
+              <a:latin typeface="Cambria Math" panose="02040503050406030204" pitchFamily="18" charset="0"/>
+              <a:ea typeface="Open Sans" panose="020B0606030504020204" pitchFamily="34" charset="0"/>
+              <a:cs typeface="Open Sans" panose="020B0606030504020204" pitchFamily="34" charset="0"/>
+            </a:endParaRPr>
+          </a:p>
+          <a:p>
+            <a:pPr algn="ctr">
+              <a:lnSpc>
+                <a:spcPct val="110000"/>
+              </a:lnSpc>
+            </a:pPr>
+            <a:endParaRPr lang="en-US" i="1" dirty="0">
+              <a:latin typeface="Cambria Math" panose="02040503050406030204" pitchFamily="18" charset="0"/>
+              <a:ea typeface="Open Sans" panose="020B0606030504020204" pitchFamily="34" charset="0"/>
+              <a:cs typeface="Open Sans" panose="020B0606030504020204" pitchFamily="34" charset="0"/>
+            </a:endParaRPr>
+          </a:p>
+          <a:p>
+            <a:pPr algn="ctr">
+              <a:lnSpc>
+                <a:spcPct val="110000"/>
+              </a:lnSpc>
+            </a:pPr>
+            <a:endParaRPr lang="en-US" b="0" i="1" dirty="0">
+              <a:latin typeface="Cambria Math" panose="02040503050406030204" pitchFamily="18" charset="0"/>
+              <a:ea typeface="Open Sans" panose="020B0606030504020204" pitchFamily="34" charset="0"/>
+              <a:cs typeface="Open Sans" panose="020B0606030504020204" pitchFamily="34" charset="0"/>
+            </a:endParaRPr>
+          </a:p>
+          <a:p>
+            <a:pPr algn="ctr">
+              <a:lnSpc>
+                <a:spcPct val="110000"/>
+              </a:lnSpc>
+            </a:pPr>
+            <a:endParaRPr lang="en-US" i="1" dirty="0">
+              <a:latin typeface="Cambria Math" panose="02040503050406030204" pitchFamily="18" charset="0"/>
+              <a:ea typeface="Open Sans" panose="020B0606030504020204" pitchFamily="34" charset="0"/>
+              <a:cs typeface="Open Sans" panose="020B0606030504020204" pitchFamily="34" charset="0"/>
+            </a:endParaRPr>
+          </a:p>
+          <a:p>
+            <a:pPr algn="ctr">
+              <a:lnSpc>
+                <a:spcPct val="110000"/>
+              </a:lnSpc>
+            </a:pPr>
+            <a:endParaRPr lang="en-US" b="0" i="1" dirty="0">
+              <a:latin typeface="Cambria Math" panose="02040503050406030204" pitchFamily="18" charset="0"/>
+              <a:ea typeface="Open Sans" panose="020B0606030504020204" pitchFamily="34" charset="0"/>
+              <a:cs typeface="Open Sans" panose="020B0606030504020204" pitchFamily="34" charset="0"/>
+            </a:endParaRPr>
+          </a:p>
+          <a:p>
+            <a:pPr algn="ctr">
+              <a:lnSpc>
+                <a:spcPct val="110000"/>
+              </a:lnSpc>
+            </a:pPr>
+            <a:endParaRPr lang="en-US" i="1" dirty="0">
+              <a:latin typeface="Cambria Math" panose="02040503050406030204" pitchFamily="18" charset="0"/>
+              <a:ea typeface="Open Sans" panose="020B0606030504020204" pitchFamily="34" charset="0"/>
+              <a:cs typeface="Open Sans" panose="020B0606030504020204" pitchFamily="34" charset="0"/>
+            </a:endParaRPr>
+          </a:p>
+          <a:p>
+            <a:pPr algn="ctr">
+              <a:lnSpc>
+                <a:spcPct val="110000"/>
+              </a:lnSpc>
+            </a:pPr>
+            <a:endParaRPr lang="en-US" i="1" dirty="0">
+              <a:latin typeface="Cambria Math" panose="02040503050406030204" pitchFamily="18" charset="0"/>
+              <a:ea typeface="Open Sans" panose="020B0606030504020204" pitchFamily="34" charset="0"/>
+              <a:cs typeface="Open Sans" panose="020B0606030504020204" pitchFamily="34" charset="0"/>
+            </a:endParaRPr>
+          </a:p>
         </p:txBody>
       </p:sp>
       <p:sp>
@@ -7141,8 +7225,8 @@
         </p:nvSpPr>
         <p:spPr bwMode="auto">
           <a:xfrm>
-            <a:off x="8818588" y="4755724"/>
-            <a:ext cx="7268693" cy="582201"/>
+            <a:off x="16193259" y="4755722"/>
+            <a:ext cx="8185619" cy="582201"/>
           </a:xfrm>
           <a:prstGeom prst="rect">
             <a:avLst/>
@@ -7194,7 +7278,7 @@
           <p:nvPr/>
         </p:nvPicPr>
         <p:blipFill>
-          <a:blip r:embed="rId7">
+          <a:blip r:embed="rId4">
             <a:extLst>
               <a:ext uri="{28A0092B-C50C-407E-A947-70E740481C1C}">
                 <a14:useLocalDpi xmlns:a14="http://schemas.microsoft.com/office/drawing/2010/main" val="0"/>
@@ -7207,8 +7291,8 @@
         </p:blipFill>
         <p:spPr>
           <a:xfrm>
-            <a:off x="9638843" y="7385261"/>
-            <a:ext cx="5575300" cy="6705600"/>
+            <a:off x="17781800" y="6871033"/>
+            <a:ext cx="5251453" cy="6316098"/>
           </a:xfrm>
           <a:prstGeom prst="rect">
             <a:avLst/>
@@ -7231,8 +7315,8 @@
         </p:nvSpPr>
         <p:spPr bwMode="auto">
           <a:xfrm>
-            <a:off x="16849071" y="5577171"/>
-            <a:ext cx="7268693" cy="4569649"/>
+            <a:off x="24878694" y="5572470"/>
+            <a:ext cx="7268693" cy="5923866"/>
           </a:xfrm>
           <a:prstGeom prst="rect">
             <a:avLst/>
@@ -7375,7 +7459,7 @@
                 <a:ea typeface="Open Sans" panose="020B0606030504020204" pitchFamily="34" charset="0"/>
                 <a:cs typeface="Open Sans" panose="020B0606030504020204" pitchFamily="34" charset="0"/>
               </a:rPr>
-              <a:t>I-Cat x I-Cat Examples:</a:t>
+              <a:t>I-Cat x I-Cat Example:</a:t>
             </a:r>
           </a:p>
           <a:p>
@@ -7433,6 +7517,54 @@
               </a:lnSpc>
             </a:pPr>
             <a:endParaRPr lang="en-US" i="1" dirty="0">
+              <a:latin typeface="Cambria Math" panose="02040503050406030204" pitchFamily="18" charset="0"/>
+              <a:ea typeface="Open Sans" panose="020B0606030504020204" pitchFamily="34" charset="0"/>
+              <a:cs typeface="Open Sans" panose="020B0606030504020204" pitchFamily="34" charset="0"/>
+            </a:endParaRPr>
+          </a:p>
+          <a:p>
+            <a:pPr algn="ctr">
+              <a:lnSpc>
+                <a:spcPct val="110000"/>
+              </a:lnSpc>
+            </a:pPr>
+            <a:endParaRPr lang="en-US" i="1" dirty="0">
+              <a:latin typeface="Cambria Math" panose="02040503050406030204" pitchFamily="18" charset="0"/>
+              <a:ea typeface="Open Sans" panose="020B0606030504020204" pitchFamily="34" charset="0"/>
+              <a:cs typeface="Open Sans" panose="020B0606030504020204" pitchFamily="34" charset="0"/>
+            </a:endParaRPr>
+          </a:p>
+          <a:p>
+            <a:pPr algn="ctr">
+              <a:lnSpc>
+                <a:spcPct val="110000"/>
+              </a:lnSpc>
+            </a:pPr>
+            <a:endParaRPr lang="en-US" b="0" i="1" dirty="0">
+              <a:latin typeface="Cambria Math" panose="02040503050406030204" pitchFamily="18" charset="0"/>
+              <a:ea typeface="Open Sans" panose="020B0606030504020204" pitchFamily="34" charset="0"/>
+              <a:cs typeface="Open Sans" panose="020B0606030504020204" pitchFamily="34" charset="0"/>
+            </a:endParaRPr>
+          </a:p>
+          <a:p>
+            <a:pPr algn="ctr">
+              <a:lnSpc>
+                <a:spcPct val="110000"/>
+              </a:lnSpc>
+            </a:pPr>
+            <a:endParaRPr lang="en-US" i="1" dirty="0">
+              <a:latin typeface="Cambria Math" panose="02040503050406030204" pitchFamily="18" charset="0"/>
+              <a:ea typeface="Open Sans" panose="020B0606030504020204" pitchFamily="34" charset="0"/>
+              <a:cs typeface="Open Sans" panose="020B0606030504020204" pitchFamily="34" charset="0"/>
+            </a:endParaRPr>
+          </a:p>
+          <a:p>
+            <a:pPr algn="ctr">
+              <a:lnSpc>
+                <a:spcPct val="110000"/>
+              </a:lnSpc>
+            </a:pPr>
+            <a:endParaRPr lang="en-US" b="0" i="1" dirty="0">
               <a:latin typeface="Cambria Math" panose="02040503050406030204" pitchFamily="18" charset="0"/>
               <a:ea typeface="Open Sans" panose="020B0606030504020204" pitchFamily="34" charset="0"/>
               <a:cs typeface="Open Sans" panose="020B0606030504020204" pitchFamily="34" charset="0"/>
@@ -7540,7 +7672,7 @@
         </p:nvSpPr>
         <p:spPr bwMode="auto">
           <a:xfrm>
-            <a:off x="16868823" y="4755724"/>
+            <a:off x="24878694" y="4755723"/>
             <a:ext cx="7268693" cy="582201"/>
           </a:xfrm>
           <a:prstGeom prst="rect">
@@ -7578,6 +7710,1104 @@
           </a:p>
         </p:txBody>
       </p:sp>
+      <p:sp>
+        <p:nvSpPr>
+          <p:cNvPr id="42" name="TextBox 41">
+            <a:extLst>
+              <a:ext uri="{FF2B5EF4-FFF2-40B4-BE49-F238E27FC236}">
+                <a16:creationId xmlns:a16="http://schemas.microsoft.com/office/drawing/2014/main" id="{68FF7854-D008-3271-1B76-D3C5BAD8A8BB}"/>
+              </a:ext>
+            </a:extLst>
+          </p:cNvPr>
+          <p:cNvSpPr txBox="1">
+            <a:spLocks noChangeArrowheads="1"/>
+          </p:cNvSpPr>
+          <p:nvPr/>
+        </p:nvSpPr>
+        <p:spPr bwMode="auto">
+          <a:xfrm>
+            <a:off x="8483367" y="5572470"/>
+            <a:ext cx="7268693" cy="13372059"/>
+          </a:xfrm>
+          <a:prstGeom prst="rect">
+            <a:avLst/>
+          </a:prstGeom>
+          <a:solidFill>
+            <a:schemeClr val="bg1"/>
+          </a:solidFill>
+          <a:ln w="9525">
+            <a:solidFill>
+              <a:srgbClr val="000000"/>
+            </a:solidFill>
+            <a:miter lim="800000"/>
+            <a:headEnd/>
+            <a:tailEnd/>
+          </a:ln>
+        </p:spPr>
+        <p:txBody>
+          <a:bodyPr wrap="square" lIns="91440" tIns="91440" rIns="91440" bIns="91440">
+            <a:spAutoFit/>
+          </a:bodyPr>
+          <a:lstStyle>
+            <a:defPPr>
+              <a:defRPr kern="1200"/>
+            </a:defPPr>
+            <a:lvl1pPr eaLnBrk="0" hangingPunct="0">
+              <a:defRPr sz="2000">
+                <a:solidFill>
+                  <a:schemeClr val="tx1"/>
+                </a:solidFill>
+                <a:latin typeface="Arial"/>
+                <a:ea typeface="ＭＳ Ｐゴシック" pitchFamily="-106" charset="-128"/>
+              </a:defRPr>
+            </a:lvl1pPr>
+            <a:lvl2pPr eaLnBrk="0" hangingPunct="0">
+              <a:defRPr sz="2000">
+                <a:solidFill>
+                  <a:schemeClr val="tx1"/>
+                </a:solidFill>
+                <a:latin typeface="Arial"/>
+                <a:ea typeface="ＭＳ Ｐゴシック" pitchFamily="-106" charset="-128"/>
+              </a:defRPr>
+            </a:lvl2pPr>
+            <a:lvl3pPr marL="1143000" indent="-228600" eaLnBrk="0" hangingPunct="0">
+              <a:defRPr sz="2000">
+                <a:solidFill>
+                  <a:schemeClr val="tx1"/>
+                </a:solidFill>
+                <a:latin typeface="Arial"/>
+                <a:ea typeface="ＭＳ Ｐゴシック" pitchFamily="-106" charset="-128"/>
+              </a:defRPr>
+            </a:lvl3pPr>
+            <a:lvl4pPr marL="1600200" indent="-228600" eaLnBrk="0" hangingPunct="0">
+              <a:defRPr sz="2000">
+                <a:solidFill>
+                  <a:schemeClr val="tx1"/>
+                </a:solidFill>
+                <a:latin typeface="Arial"/>
+                <a:ea typeface="ＭＳ Ｐゴシック" pitchFamily="-106" charset="-128"/>
+              </a:defRPr>
+            </a:lvl4pPr>
+            <a:lvl5pPr marL="2057400" indent="-228600" eaLnBrk="0" hangingPunct="0">
+              <a:defRPr sz="2000">
+                <a:solidFill>
+                  <a:schemeClr val="tx1"/>
+                </a:solidFill>
+                <a:latin typeface="Arial"/>
+                <a:ea typeface="ＭＳ Ｐゴシック" pitchFamily="-106" charset="-128"/>
+              </a:defRPr>
+            </a:lvl5pPr>
+            <a:lvl6pPr marL="2514600" indent="-228600" eaLnBrk="0" fontAlgn="base" hangingPunct="0">
+              <a:spcBef>
+                <a:spcPct val="0"/>
+              </a:spcBef>
+              <a:spcAft>
+                <a:spcPct val="0"/>
+              </a:spcAft>
+              <a:defRPr sz="2000">
+                <a:solidFill>
+                  <a:schemeClr val="tx1"/>
+                </a:solidFill>
+                <a:latin typeface="Arial"/>
+                <a:ea typeface="ＭＳ Ｐゴシック" pitchFamily="-106" charset="-128"/>
+              </a:defRPr>
+            </a:lvl6pPr>
+            <a:lvl7pPr marL="2971800" indent="-228600" eaLnBrk="0" fontAlgn="base" hangingPunct="0">
+              <a:spcBef>
+                <a:spcPct val="0"/>
+              </a:spcBef>
+              <a:spcAft>
+                <a:spcPct val="0"/>
+              </a:spcAft>
+              <a:defRPr sz="2000">
+                <a:solidFill>
+                  <a:schemeClr val="tx1"/>
+                </a:solidFill>
+                <a:latin typeface="Arial"/>
+                <a:ea typeface="ＭＳ Ｐゴシック" pitchFamily="-106" charset="-128"/>
+              </a:defRPr>
+            </a:lvl7pPr>
+            <a:lvl8pPr marL="3429000" indent="-228600" eaLnBrk="0" fontAlgn="base" hangingPunct="0">
+              <a:spcBef>
+                <a:spcPct val="0"/>
+              </a:spcBef>
+              <a:spcAft>
+                <a:spcPct val="0"/>
+              </a:spcAft>
+              <a:defRPr sz="2000">
+                <a:solidFill>
+                  <a:schemeClr val="tx1"/>
+                </a:solidFill>
+                <a:latin typeface="Arial"/>
+                <a:ea typeface="ＭＳ Ｐゴシック" pitchFamily="-106" charset="-128"/>
+              </a:defRPr>
+            </a:lvl8pPr>
+            <a:lvl9pPr marL="3886200" indent="-228600" eaLnBrk="0" fontAlgn="base" hangingPunct="0">
+              <a:spcBef>
+                <a:spcPct val="0"/>
+              </a:spcBef>
+              <a:spcAft>
+                <a:spcPct val="0"/>
+              </a:spcAft>
+              <a:defRPr sz="2000">
+                <a:solidFill>
+                  <a:schemeClr val="tx1"/>
+                </a:solidFill>
+                <a:latin typeface="Arial"/>
+                <a:ea typeface="ＭＳ Ｐゴシック" pitchFamily="-106" charset="-128"/>
+              </a:defRPr>
+            </a:lvl9pPr>
+          </a:lstStyle>
+          <a:p>
+            <a:pPr algn="just">
+              <a:lnSpc>
+                <a:spcPct val="110000"/>
+              </a:lnSpc>
+            </a:pPr>
+            <a:r>
+              <a:rPr lang="en-US" b="1" dirty="0">
+                <a:latin typeface="Open Sans" panose="020B0606030504020204" pitchFamily="34" charset="0"/>
+                <a:ea typeface="Open Sans" panose="020B0606030504020204" pitchFamily="34" charset="0"/>
+                <a:cs typeface="Open Sans" panose="020B0606030504020204" pitchFamily="34" charset="0"/>
+              </a:rPr>
+              <a:t>Addition Examples:</a:t>
+            </a:r>
+          </a:p>
+          <a:p>
+            <a:pPr algn="ctr">
+              <a:lnSpc>
+                <a:spcPct val="110000"/>
+              </a:lnSpc>
+            </a:pPr>
+            <a:endParaRPr lang="en-US" b="1" dirty="0">
+              <a:latin typeface="Open Sans" panose="020B0606030504020204" pitchFamily="34" charset="0"/>
+              <a:ea typeface="Open Sans" panose="020B0606030504020204" pitchFamily="34" charset="0"/>
+              <a:cs typeface="Open Sans" panose="020B0606030504020204" pitchFamily="34" charset="0"/>
+            </a:endParaRPr>
+          </a:p>
+          <a:p>
+            <a:pPr algn="just">
+              <a:lnSpc>
+                <a:spcPct val="110000"/>
+              </a:lnSpc>
+            </a:pPr>
+            <a:endParaRPr lang="en-US" b="1" dirty="0">
+              <a:latin typeface="Open Sans" panose="020B0606030504020204" pitchFamily="34" charset="0"/>
+              <a:ea typeface="Open Sans" panose="020B0606030504020204" pitchFamily="34" charset="0"/>
+              <a:cs typeface="Open Sans" panose="020B0606030504020204" pitchFamily="34" charset="0"/>
+            </a:endParaRPr>
+          </a:p>
+          <a:p>
+            <a:pPr algn="ctr">
+              <a:lnSpc>
+                <a:spcPct val="110000"/>
+              </a:lnSpc>
+            </a:pPr>
+            <a:endParaRPr lang="en-US" b="0" i="1" dirty="0">
+              <a:latin typeface="Cambria Math" panose="02040503050406030204" pitchFamily="18" charset="0"/>
+              <a:ea typeface="Open Sans" panose="020B0606030504020204" pitchFamily="34" charset="0"/>
+              <a:cs typeface="Open Sans" panose="020B0606030504020204" pitchFamily="34" charset="0"/>
+            </a:endParaRPr>
+          </a:p>
+          <a:p>
+            <a:pPr algn="ctr">
+              <a:lnSpc>
+                <a:spcPct val="110000"/>
+              </a:lnSpc>
+            </a:pPr>
+            <a:endParaRPr lang="en-US" i="1" dirty="0">
+              <a:latin typeface="Cambria Math" panose="02040503050406030204" pitchFamily="18" charset="0"/>
+              <a:ea typeface="Open Sans" panose="020B0606030504020204" pitchFamily="34" charset="0"/>
+              <a:cs typeface="Open Sans" panose="020B0606030504020204" pitchFamily="34" charset="0"/>
+            </a:endParaRPr>
+          </a:p>
+          <a:p>
+            <a:pPr algn="ctr">
+              <a:lnSpc>
+                <a:spcPct val="110000"/>
+              </a:lnSpc>
+            </a:pPr>
+            <a:endParaRPr lang="en-US" i="1" dirty="0">
+              <a:latin typeface="Cambria Math" panose="02040503050406030204" pitchFamily="18" charset="0"/>
+              <a:ea typeface="Open Sans" panose="020B0606030504020204" pitchFamily="34" charset="0"/>
+              <a:cs typeface="Open Sans" panose="020B0606030504020204" pitchFamily="34" charset="0"/>
+            </a:endParaRPr>
+          </a:p>
+          <a:p>
+            <a:pPr algn="ctr">
+              <a:lnSpc>
+                <a:spcPct val="110000"/>
+              </a:lnSpc>
+            </a:pPr>
+            <a:endParaRPr lang="en-US" i="1" dirty="0">
+              <a:latin typeface="Cambria Math" panose="02040503050406030204" pitchFamily="18" charset="0"/>
+              <a:ea typeface="Open Sans" panose="020B0606030504020204" pitchFamily="34" charset="0"/>
+              <a:cs typeface="Open Sans" panose="020B0606030504020204" pitchFamily="34" charset="0"/>
+            </a:endParaRPr>
+          </a:p>
+          <a:p>
+            <a:pPr algn="ctr">
+              <a:lnSpc>
+                <a:spcPct val="110000"/>
+              </a:lnSpc>
+            </a:pPr>
+            <a:endParaRPr lang="en-US" i="1" dirty="0">
+              <a:latin typeface="Cambria Math" panose="02040503050406030204" pitchFamily="18" charset="0"/>
+              <a:ea typeface="Open Sans" panose="020B0606030504020204" pitchFamily="34" charset="0"/>
+              <a:cs typeface="Open Sans" panose="020B0606030504020204" pitchFamily="34" charset="0"/>
+            </a:endParaRPr>
+          </a:p>
+          <a:p>
+            <a:pPr algn="ctr">
+              <a:lnSpc>
+                <a:spcPct val="110000"/>
+              </a:lnSpc>
+            </a:pPr>
+            <a:endParaRPr lang="en-US" i="1" dirty="0">
+              <a:latin typeface="Cambria Math" panose="02040503050406030204" pitchFamily="18" charset="0"/>
+              <a:ea typeface="Open Sans" panose="020B0606030504020204" pitchFamily="34" charset="0"/>
+              <a:cs typeface="Open Sans" panose="020B0606030504020204" pitchFamily="34" charset="0"/>
+            </a:endParaRPr>
+          </a:p>
+          <a:p>
+            <a:pPr algn="ctr">
+              <a:lnSpc>
+                <a:spcPct val="110000"/>
+              </a:lnSpc>
+            </a:pPr>
+            <a:endParaRPr lang="en-US" i="1" dirty="0">
+              <a:latin typeface="Cambria Math" panose="02040503050406030204" pitchFamily="18" charset="0"/>
+              <a:ea typeface="Open Sans" panose="020B0606030504020204" pitchFamily="34" charset="0"/>
+              <a:cs typeface="Open Sans" panose="020B0606030504020204" pitchFamily="34" charset="0"/>
+            </a:endParaRPr>
+          </a:p>
+          <a:p>
+            <a:pPr algn="ctr">
+              <a:lnSpc>
+                <a:spcPct val="110000"/>
+              </a:lnSpc>
+            </a:pPr>
+            <a:endParaRPr lang="en-US" i="1" dirty="0">
+              <a:latin typeface="Cambria Math" panose="02040503050406030204" pitchFamily="18" charset="0"/>
+              <a:ea typeface="Open Sans" panose="020B0606030504020204" pitchFamily="34" charset="0"/>
+              <a:cs typeface="Open Sans" panose="020B0606030504020204" pitchFamily="34" charset="0"/>
+            </a:endParaRPr>
+          </a:p>
+          <a:p>
+            <a:pPr algn="ctr">
+              <a:lnSpc>
+                <a:spcPct val="110000"/>
+              </a:lnSpc>
+            </a:pPr>
+            <a:endParaRPr lang="en-US" b="0" i="1" dirty="0">
+              <a:latin typeface="Cambria Math" panose="02040503050406030204" pitchFamily="18" charset="0"/>
+              <a:ea typeface="Open Sans" panose="020B0606030504020204" pitchFamily="34" charset="0"/>
+              <a:cs typeface="Open Sans" panose="020B0606030504020204" pitchFamily="34" charset="0"/>
+            </a:endParaRPr>
+          </a:p>
+          <a:p>
+            <a:pPr algn="ctr">
+              <a:lnSpc>
+                <a:spcPct val="110000"/>
+              </a:lnSpc>
+            </a:pPr>
+            <a:endParaRPr lang="en-US" i="1" dirty="0">
+              <a:latin typeface="Cambria Math" panose="02040503050406030204" pitchFamily="18" charset="0"/>
+              <a:ea typeface="Open Sans" panose="020B0606030504020204" pitchFamily="34" charset="0"/>
+              <a:cs typeface="Open Sans" panose="020B0606030504020204" pitchFamily="34" charset="0"/>
+            </a:endParaRPr>
+          </a:p>
+          <a:p>
+            <a:pPr algn="ctr">
+              <a:lnSpc>
+                <a:spcPct val="110000"/>
+              </a:lnSpc>
+            </a:pPr>
+            <a:endParaRPr lang="en-US" b="0" i="1" dirty="0">
+              <a:latin typeface="Cambria Math" panose="02040503050406030204" pitchFamily="18" charset="0"/>
+              <a:ea typeface="Open Sans" panose="020B0606030504020204" pitchFamily="34" charset="0"/>
+              <a:cs typeface="Open Sans" panose="020B0606030504020204" pitchFamily="34" charset="0"/>
+            </a:endParaRPr>
+          </a:p>
+          <a:p>
+            <a:pPr algn="ctr">
+              <a:lnSpc>
+                <a:spcPct val="110000"/>
+              </a:lnSpc>
+            </a:pPr>
+            <a:endParaRPr lang="en-US" i="1" dirty="0">
+              <a:latin typeface="Cambria Math" panose="02040503050406030204" pitchFamily="18" charset="0"/>
+              <a:ea typeface="Open Sans" panose="020B0606030504020204" pitchFamily="34" charset="0"/>
+              <a:cs typeface="Open Sans" panose="020B0606030504020204" pitchFamily="34" charset="0"/>
+            </a:endParaRPr>
+          </a:p>
+          <a:p>
+            <a:pPr algn="ctr">
+              <a:lnSpc>
+                <a:spcPct val="110000"/>
+              </a:lnSpc>
+            </a:pPr>
+            <a:endParaRPr lang="en-US" b="0" i="1" dirty="0">
+              <a:latin typeface="Cambria Math" panose="02040503050406030204" pitchFamily="18" charset="0"/>
+              <a:ea typeface="Open Sans" panose="020B0606030504020204" pitchFamily="34" charset="0"/>
+              <a:cs typeface="Open Sans" panose="020B0606030504020204" pitchFamily="34" charset="0"/>
+            </a:endParaRPr>
+          </a:p>
+          <a:p>
+            <a:pPr algn="ctr">
+              <a:lnSpc>
+                <a:spcPct val="110000"/>
+              </a:lnSpc>
+            </a:pPr>
+            <a:endParaRPr lang="en-US" i="1" dirty="0">
+              <a:latin typeface="Cambria Math" panose="02040503050406030204" pitchFamily="18" charset="0"/>
+              <a:ea typeface="Open Sans" panose="020B0606030504020204" pitchFamily="34" charset="0"/>
+              <a:cs typeface="Open Sans" panose="020B0606030504020204" pitchFamily="34" charset="0"/>
+            </a:endParaRPr>
+          </a:p>
+          <a:p>
+            <a:pPr algn="ctr">
+              <a:lnSpc>
+                <a:spcPct val="110000"/>
+              </a:lnSpc>
+            </a:pPr>
+            <a:endParaRPr lang="en-US" b="0" i="1" dirty="0">
+              <a:latin typeface="Cambria Math" panose="02040503050406030204" pitchFamily="18" charset="0"/>
+              <a:ea typeface="Open Sans" panose="020B0606030504020204" pitchFamily="34" charset="0"/>
+              <a:cs typeface="Open Sans" panose="020B0606030504020204" pitchFamily="34" charset="0"/>
+            </a:endParaRPr>
+          </a:p>
+          <a:p>
+            <a:pPr algn="ctr">
+              <a:lnSpc>
+                <a:spcPct val="110000"/>
+              </a:lnSpc>
+            </a:pPr>
+            <a:endParaRPr lang="en-US" i="1" dirty="0">
+              <a:latin typeface="Cambria Math" panose="02040503050406030204" pitchFamily="18" charset="0"/>
+              <a:ea typeface="Open Sans" panose="020B0606030504020204" pitchFamily="34" charset="0"/>
+              <a:cs typeface="Open Sans" panose="020B0606030504020204" pitchFamily="34" charset="0"/>
+            </a:endParaRPr>
+          </a:p>
+          <a:p>
+            <a:pPr algn="ctr">
+              <a:lnSpc>
+                <a:spcPct val="110000"/>
+              </a:lnSpc>
+            </a:pPr>
+            <a:endParaRPr lang="en-US" b="0" i="1" dirty="0">
+              <a:latin typeface="Cambria Math" panose="02040503050406030204" pitchFamily="18" charset="0"/>
+              <a:ea typeface="Open Sans" panose="020B0606030504020204" pitchFamily="34" charset="0"/>
+              <a:cs typeface="Open Sans" panose="020B0606030504020204" pitchFamily="34" charset="0"/>
+            </a:endParaRPr>
+          </a:p>
+          <a:p>
+            <a:pPr algn="ctr">
+              <a:lnSpc>
+                <a:spcPct val="110000"/>
+              </a:lnSpc>
+            </a:pPr>
+            <a:endParaRPr lang="en-US" i="1" dirty="0">
+              <a:latin typeface="Cambria Math" panose="02040503050406030204" pitchFamily="18" charset="0"/>
+              <a:ea typeface="Open Sans" panose="020B0606030504020204" pitchFamily="34" charset="0"/>
+              <a:cs typeface="Open Sans" panose="020B0606030504020204" pitchFamily="34" charset="0"/>
+            </a:endParaRPr>
+          </a:p>
+          <a:p>
+            <a:pPr algn="ctr">
+              <a:lnSpc>
+                <a:spcPct val="110000"/>
+              </a:lnSpc>
+            </a:pPr>
+            <a:endParaRPr lang="en-US" b="0" i="1" dirty="0">
+              <a:latin typeface="Cambria Math" panose="02040503050406030204" pitchFamily="18" charset="0"/>
+              <a:ea typeface="Open Sans" panose="020B0606030504020204" pitchFamily="34" charset="0"/>
+              <a:cs typeface="Open Sans" panose="020B0606030504020204" pitchFamily="34" charset="0"/>
+            </a:endParaRPr>
+          </a:p>
+          <a:p>
+            <a:pPr algn="ctr">
+              <a:lnSpc>
+                <a:spcPct val="110000"/>
+              </a:lnSpc>
+            </a:pPr>
+            <a:endParaRPr lang="en-US" i="1" dirty="0">
+              <a:latin typeface="Cambria Math" panose="02040503050406030204" pitchFamily="18" charset="0"/>
+              <a:ea typeface="Open Sans" panose="020B0606030504020204" pitchFamily="34" charset="0"/>
+              <a:cs typeface="Open Sans" panose="020B0606030504020204" pitchFamily="34" charset="0"/>
+            </a:endParaRPr>
+          </a:p>
+          <a:p>
+            <a:pPr algn="ctr">
+              <a:lnSpc>
+                <a:spcPct val="110000"/>
+              </a:lnSpc>
+            </a:pPr>
+            <a:endParaRPr lang="en-US" i="1" dirty="0">
+              <a:latin typeface="Cambria Math" panose="02040503050406030204" pitchFamily="18" charset="0"/>
+              <a:ea typeface="Open Sans" panose="020B0606030504020204" pitchFamily="34" charset="0"/>
+              <a:cs typeface="Open Sans" panose="020B0606030504020204" pitchFamily="34" charset="0"/>
+            </a:endParaRPr>
+          </a:p>
+          <a:p>
+            <a:pPr algn="ctr">
+              <a:lnSpc>
+                <a:spcPct val="110000"/>
+              </a:lnSpc>
+            </a:pPr>
+            <a:endParaRPr lang="en-US" i="1" dirty="0">
+              <a:latin typeface="Cambria Math" panose="02040503050406030204" pitchFamily="18" charset="0"/>
+              <a:ea typeface="Open Sans" panose="020B0606030504020204" pitchFamily="34" charset="0"/>
+              <a:cs typeface="Open Sans" panose="020B0606030504020204" pitchFamily="34" charset="0"/>
+            </a:endParaRPr>
+          </a:p>
+          <a:p>
+            <a:pPr algn="ctr">
+              <a:lnSpc>
+                <a:spcPct val="110000"/>
+              </a:lnSpc>
+            </a:pPr>
+            <a:endParaRPr lang="en-US" b="0" i="1" dirty="0">
+              <a:latin typeface="Cambria Math" panose="02040503050406030204" pitchFamily="18" charset="0"/>
+              <a:ea typeface="Open Sans" panose="020B0606030504020204" pitchFamily="34" charset="0"/>
+              <a:cs typeface="Open Sans" panose="020B0606030504020204" pitchFamily="34" charset="0"/>
+            </a:endParaRPr>
+          </a:p>
+          <a:p>
+            <a:pPr algn="ctr">
+              <a:lnSpc>
+                <a:spcPct val="110000"/>
+              </a:lnSpc>
+            </a:pPr>
+            <a:endParaRPr lang="en-US" i="1" dirty="0">
+              <a:latin typeface="Cambria Math" panose="02040503050406030204" pitchFamily="18" charset="0"/>
+              <a:ea typeface="Open Sans" panose="020B0606030504020204" pitchFamily="34" charset="0"/>
+              <a:cs typeface="Open Sans" panose="020B0606030504020204" pitchFamily="34" charset="0"/>
+            </a:endParaRPr>
+          </a:p>
+          <a:p>
+            <a:pPr algn="ctr">
+              <a:lnSpc>
+                <a:spcPct val="110000"/>
+              </a:lnSpc>
+            </a:pPr>
+            <a:endParaRPr lang="en-US" i="1" dirty="0">
+              <a:latin typeface="Cambria Math" panose="02040503050406030204" pitchFamily="18" charset="0"/>
+              <a:ea typeface="Open Sans" panose="020B0606030504020204" pitchFamily="34" charset="0"/>
+              <a:cs typeface="Open Sans" panose="020B0606030504020204" pitchFamily="34" charset="0"/>
+            </a:endParaRPr>
+          </a:p>
+          <a:p>
+            <a:pPr algn="ctr">
+              <a:lnSpc>
+                <a:spcPct val="110000"/>
+              </a:lnSpc>
+            </a:pPr>
+            <a:endParaRPr lang="en-US" i="1" dirty="0">
+              <a:latin typeface="Cambria Math" panose="02040503050406030204" pitchFamily="18" charset="0"/>
+              <a:ea typeface="Open Sans" panose="020B0606030504020204" pitchFamily="34" charset="0"/>
+              <a:cs typeface="Open Sans" panose="020B0606030504020204" pitchFamily="34" charset="0"/>
+            </a:endParaRPr>
+          </a:p>
+          <a:p>
+            <a:pPr algn="ctr">
+              <a:lnSpc>
+                <a:spcPct val="110000"/>
+              </a:lnSpc>
+            </a:pPr>
+            <a:endParaRPr lang="en-US" i="1" dirty="0">
+              <a:latin typeface="Cambria Math" panose="02040503050406030204" pitchFamily="18" charset="0"/>
+              <a:ea typeface="Open Sans" panose="020B0606030504020204" pitchFamily="34" charset="0"/>
+              <a:cs typeface="Open Sans" panose="020B0606030504020204" pitchFamily="34" charset="0"/>
+            </a:endParaRPr>
+          </a:p>
+          <a:p>
+            <a:pPr algn="ctr">
+              <a:lnSpc>
+                <a:spcPct val="110000"/>
+              </a:lnSpc>
+            </a:pPr>
+            <a:endParaRPr lang="en-US" i="1" dirty="0">
+              <a:latin typeface="Cambria Math" panose="02040503050406030204" pitchFamily="18" charset="0"/>
+              <a:ea typeface="Open Sans" panose="020B0606030504020204" pitchFamily="34" charset="0"/>
+              <a:cs typeface="Open Sans" panose="020B0606030504020204" pitchFamily="34" charset="0"/>
+            </a:endParaRPr>
+          </a:p>
+          <a:p>
+            <a:pPr algn="ctr">
+              <a:lnSpc>
+                <a:spcPct val="110000"/>
+              </a:lnSpc>
+            </a:pPr>
+            <a:endParaRPr lang="en-US" i="1" dirty="0">
+              <a:latin typeface="Cambria Math" panose="02040503050406030204" pitchFamily="18" charset="0"/>
+              <a:ea typeface="Open Sans" panose="020B0606030504020204" pitchFamily="34" charset="0"/>
+              <a:cs typeface="Open Sans" panose="020B0606030504020204" pitchFamily="34" charset="0"/>
+            </a:endParaRPr>
+          </a:p>
+          <a:p>
+            <a:pPr algn="ctr">
+              <a:lnSpc>
+                <a:spcPct val="110000"/>
+              </a:lnSpc>
+            </a:pPr>
+            <a:endParaRPr lang="en-US" i="1" dirty="0">
+              <a:latin typeface="Cambria Math" panose="02040503050406030204" pitchFamily="18" charset="0"/>
+              <a:ea typeface="Open Sans" panose="020B0606030504020204" pitchFamily="34" charset="0"/>
+              <a:cs typeface="Open Sans" panose="020B0606030504020204" pitchFamily="34" charset="0"/>
+            </a:endParaRPr>
+          </a:p>
+          <a:p>
+            <a:pPr algn="ctr">
+              <a:lnSpc>
+                <a:spcPct val="110000"/>
+              </a:lnSpc>
+            </a:pPr>
+            <a:endParaRPr lang="en-US" i="1" dirty="0">
+              <a:latin typeface="Cambria Math" panose="02040503050406030204" pitchFamily="18" charset="0"/>
+              <a:ea typeface="Open Sans" panose="020B0606030504020204" pitchFamily="34" charset="0"/>
+              <a:cs typeface="Open Sans" panose="020B0606030504020204" pitchFamily="34" charset="0"/>
+            </a:endParaRPr>
+          </a:p>
+          <a:p>
+            <a:pPr algn="ctr">
+              <a:lnSpc>
+                <a:spcPct val="110000"/>
+              </a:lnSpc>
+            </a:pPr>
+            <a:endParaRPr lang="en-US" i="1" dirty="0">
+              <a:latin typeface="Cambria Math" panose="02040503050406030204" pitchFamily="18" charset="0"/>
+              <a:ea typeface="Open Sans" panose="020B0606030504020204" pitchFamily="34" charset="0"/>
+              <a:cs typeface="Open Sans" panose="020B0606030504020204" pitchFamily="34" charset="0"/>
+            </a:endParaRPr>
+          </a:p>
+          <a:p>
+            <a:pPr algn="ctr">
+              <a:lnSpc>
+                <a:spcPct val="110000"/>
+              </a:lnSpc>
+            </a:pPr>
+            <a:endParaRPr lang="en-US" i="1" dirty="0">
+              <a:latin typeface="Cambria Math" panose="02040503050406030204" pitchFamily="18" charset="0"/>
+              <a:ea typeface="Open Sans" panose="020B0606030504020204" pitchFamily="34" charset="0"/>
+              <a:cs typeface="Open Sans" panose="020B0606030504020204" pitchFamily="34" charset="0"/>
+            </a:endParaRPr>
+          </a:p>
+          <a:p>
+            <a:pPr algn="ctr">
+              <a:lnSpc>
+                <a:spcPct val="110000"/>
+              </a:lnSpc>
+            </a:pPr>
+            <a:endParaRPr lang="en-US" i="1" dirty="0">
+              <a:latin typeface="Cambria Math" panose="02040503050406030204" pitchFamily="18" charset="0"/>
+              <a:ea typeface="Open Sans" panose="020B0606030504020204" pitchFamily="34" charset="0"/>
+              <a:cs typeface="Open Sans" panose="020B0606030504020204" pitchFamily="34" charset="0"/>
+            </a:endParaRPr>
+          </a:p>
+          <a:p>
+            <a:pPr algn="ctr">
+              <a:lnSpc>
+                <a:spcPct val="110000"/>
+              </a:lnSpc>
+            </a:pPr>
+            <a:endParaRPr lang="en-US" i="1" dirty="0">
+              <a:latin typeface="Cambria Math" panose="02040503050406030204" pitchFamily="18" charset="0"/>
+              <a:ea typeface="Open Sans" panose="020B0606030504020204" pitchFamily="34" charset="0"/>
+              <a:cs typeface="Open Sans" panose="020B0606030504020204" pitchFamily="34" charset="0"/>
+            </a:endParaRPr>
+          </a:p>
+          <a:p>
+            <a:pPr algn="ctr">
+              <a:lnSpc>
+                <a:spcPct val="110000"/>
+              </a:lnSpc>
+            </a:pPr>
+            <a:endParaRPr lang="en-US" b="0" i="1" dirty="0">
+              <a:latin typeface="Cambria Math" panose="02040503050406030204" pitchFamily="18" charset="0"/>
+              <a:ea typeface="Open Sans" panose="020B0606030504020204" pitchFamily="34" charset="0"/>
+              <a:cs typeface="Open Sans" panose="020B0606030504020204" pitchFamily="34" charset="0"/>
+            </a:endParaRPr>
+          </a:p>
+        </p:txBody>
+      </p:sp>
+      <p:sp>
+        <p:nvSpPr>
+          <p:cNvPr id="43" name="Rectangle 10">
+            <a:extLst>
+              <a:ext uri="{FF2B5EF4-FFF2-40B4-BE49-F238E27FC236}">
+                <a16:creationId xmlns:a16="http://schemas.microsoft.com/office/drawing/2014/main" id="{F9522775-0917-A637-2ED0-D78CA46CDCAC}"/>
+              </a:ext>
+            </a:extLst>
+          </p:cNvPr>
+          <p:cNvSpPr>
+            <a:spLocks noChangeArrowheads="1"/>
+          </p:cNvSpPr>
+          <p:nvPr/>
+        </p:nvSpPr>
+        <p:spPr bwMode="auto">
+          <a:xfrm>
+            <a:off x="8483367" y="4755723"/>
+            <a:ext cx="7268693" cy="582201"/>
+          </a:xfrm>
+          <a:prstGeom prst="rect">
+            <a:avLst/>
+          </a:prstGeom>
+          <a:solidFill>
+            <a:srgbClr val="1482A5"/>
+          </a:solidFill>
+          <a:ln w="12700">
+            <a:noFill/>
+            <a:miter lim="800000"/>
+          </a:ln>
+        </p:spPr>
+        <p:txBody>
+          <a:bodyPr wrap="none" lIns="182880" tIns="48768" rIns="182880" bIns="45709" anchor="ctr" anchorCtr="0"/>
+          <a:lstStyle>
+            <a:defPPr>
+              <a:defRPr kern="1200"/>
+            </a:defPPr>
+          </a:lstStyle>
+          <a:p>
+            <a:pPr algn="ctr" defTabSz="3135215">
+              <a:defRPr/>
+            </a:pPr>
+            <a:r>
+              <a:rPr lang="en-US" sz="2800" b="1" dirty="0">
+                <a:solidFill>
+                  <a:schemeClr val="bg1"/>
+                </a:solidFill>
+                <a:latin typeface="Arial" panose="020B0604020202020204" pitchFamily="34" charset="0"/>
+                <a:cs typeface="Arial" panose="020B0604020202020204" pitchFamily="34" charset="0"/>
+              </a:rPr>
+              <a:t>Operations &amp; Examples (cont.)</a:t>
+            </a:r>
+          </a:p>
+        </p:txBody>
+      </p:sp>
+      <p:grpSp>
+        <p:nvGrpSpPr>
+          <p:cNvPr id="59" name="Group 58">
+            <a:extLst>
+              <a:ext uri="{FF2B5EF4-FFF2-40B4-BE49-F238E27FC236}">
+                <a16:creationId xmlns:a16="http://schemas.microsoft.com/office/drawing/2014/main" id="{06EA08A9-EAA8-8C06-9989-D3234323F71D}"/>
+              </a:ext>
+            </a:extLst>
+          </p:cNvPr>
+          <p:cNvGrpSpPr/>
+          <p:nvPr/>
+        </p:nvGrpSpPr>
+        <p:grpSpPr>
+          <a:xfrm>
+            <a:off x="8721040" y="15021186"/>
+            <a:ext cx="6802838" cy="3529874"/>
+            <a:chOff x="9010601" y="10394569"/>
+            <a:chExt cx="6802838" cy="3529874"/>
+          </a:xfrm>
+        </p:grpSpPr>
+        <p:pic>
+          <p:nvPicPr>
+            <p:cNvPr id="49" name="Picture 48">
+              <a:extLst>
+                <a:ext uri="{FF2B5EF4-FFF2-40B4-BE49-F238E27FC236}">
+                  <a16:creationId xmlns:a16="http://schemas.microsoft.com/office/drawing/2014/main" id="{BC33A010-07EB-BB1C-F0CD-CBF7C9D67F82}"/>
+                </a:ext>
+              </a:extLst>
+            </p:cNvPr>
+            <p:cNvPicPr>
+              <a:picLocks noChangeAspect="1"/>
+            </p:cNvPicPr>
+            <p:nvPr/>
+          </p:nvPicPr>
+          <p:blipFill>
+            <a:blip r:embed="rId5">
+              <a:extLst>
+                <a:ext uri="{28A0092B-C50C-407E-A947-70E740481C1C}">
+                  <a14:useLocalDpi xmlns:a14="http://schemas.microsoft.com/office/drawing/2010/main" val="0"/>
+                </a:ext>
+              </a:extLst>
+            </a:blip>
+            <a:stretch>
+              <a:fillRect/>
+            </a:stretch>
+          </p:blipFill>
+          <p:spPr>
+            <a:xfrm>
+              <a:off x="12338719" y="10394569"/>
+              <a:ext cx="3474720" cy="3529874"/>
+            </a:xfrm>
+            <a:prstGeom prst="rect">
+              <a:avLst/>
+            </a:prstGeom>
+          </p:spPr>
+        </p:pic>
+        <p:pic>
+          <p:nvPicPr>
+            <p:cNvPr id="51" name="Picture 50">
+              <a:extLst>
+                <a:ext uri="{FF2B5EF4-FFF2-40B4-BE49-F238E27FC236}">
+                  <a16:creationId xmlns:a16="http://schemas.microsoft.com/office/drawing/2014/main" id="{B97B9133-9974-AE52-C354-C32CF578AB95}"/>
+                </a:ext>
+              </a:extLst>
+            </p:cNvPr>
+            <p:cNvPicPr>
+              <a:picLocks noChangeAspect="1"/>
+            </p:cNvPicPr>
+            <p:nvPr/>
+          </p:nvPicPr>
+          <p:blipFill>
+            <a:blip r:embed="rId6">
+              <a:extLst>
+                <a:ext uri="{28A0092B-C50C-407E-A947-70E740481C1C}">
+                  <a14:useLocalDpi xmlns:a14="http://schemas.microsoft.com/office/drawing/2010/main" val="0"/>
+                </a:ext>
+              </a:extLst>
+            </a:blip>
+            <a:stretch>
+              <a:fillRect/>
+            </a:stretch>
+          </p:blipFill>
+          <p:spPr>
+            <a:xfrm>
+              <a:off x="9010601" y="10394569"/>
+              <a:ext cx="3106591" cy="1129669"/>
+            </a:xfrm>
+            <a:prstGeom prst="rect">
+              <a:avLst/>
+            </a:prstGeom>
+          </p:spPr>
+        </p:pic>
+      </p:grpSp>
+      <p:grpSp>
+        <p:nvGrpSpPr>
+          <p:cNvPr id="60" name="Group 59">
+            <a:extLst>
+              <a:ext uri="{FF2B5EF4-FFF2-40B4-BE49-F238E27FC236}">
+                <a16:creationId xmlns:a16="http://schemas.microsoft.com/office/drawing/2014/main" id="{A662A17A-1ACF-5798-85E5-DC9D6712B66E}"/>
+              </a:ext>
+            </a:extLst>
+          </p:cNvPr>
+          <p:cNvGrpSpPr/>
+          <p:nvPr/>
+        </p:nvGrpSpPr>
+        <p:grpSpPr>
+          <a:xfrm>
+            <a:off x="8753256" y="10051620"/>
+            <a:ext cx="6743204" cy="3529874"/>
+            <a:chOff x="9041671" y="10053754"/>
+            <a:chExt cx="6743204" cy="3529874"/>
+          </a:xfrm>
+        </p:grpSpPr>
+        <p:pic>
+          <p:nvPicPr>
+            <p:cNvPr id="47" name="Picture 46">
+              <a:extLst>
+                <a:ext uri="{FF2B5EF4-FFF2-40B4-BE49-F238E27FC236}">
+                  <a16:creationId xmlns:a16="http://schemas.microsoft.com/office/drawing/2014/main" id="{50505D91-E574-2F7B-3E0E-5977FACE2CD0}"/>
+                </a:ext>
+              </a:extLst>
+            </p:cNvPr>
+            <p:cNvPicPr>
+              <a:picLocks noChangeAspect="1"/>
+            </p:cNvPicPr>
+            <p:nvPr/>
+          </p:nvPicPr>
+          <p:blipFill>
+            <a:blip r:embed="rId7">
+              <a:extLst>
+                <a:ext uri="{28A0092B-C50C-407E-A947-70E740481C1C}">
+                  <a14:useLocalDpi xmlns:a14="http://schemas.microsoft.com/office/drawing/2010/main" val="0"/>
+                </a:ext>
+              </a:extLst>
+            </a:blip>
+            <a:stretch>
+              <a:fillRect/>
+            </a:stretch>
+          </p:blipFill>
+          <p:spPr>
+            <a:xfrm>
+              <a:off x="12310155" y="10053754"/>
+              <a:ext cx="3474720" cy="3529874"/>
+            </a:xfrm>
+            <a:prstGeom prst="rect">
+              <a:avLst/>
+            </a:prstGeom>
+          </p:spPr>
+        </p:pic>
+        <p:pic>
+          <p:nvPicPr>
+            <p:cNvPr id="53" name="Picture 52">
+              <a:extLst>
+                <a:ext uri="{FF2B5EF4-FFF2-40B4-BE49-F238E27FC236}">
+                  <a16:creationId xmlns:a16="http://schemas.microsoft.com/office/drawing/2014/main" id="{B4D42461-26BA-4A57-EF64-9D88FA5AC051}"/>
+                </a:ext>
+              </a:extLst>
+            </p:cNvPr>
+            <p:cNvPicPr>
+              <a:picLocks noChangeAspect="1"/>
+            </p:cNvPicPr>
+            <p:nvPr/>
+          </p:nvPicPr>
+          <p:blipFill>
+            <a:blip r:embed="rId8">
+              <a:extLst>
+                <a:ext uri="{28A0092B-C50C-407E-A947-70E740481C1C}">
+                  <a14:useLocalDpi xmlns:a14="http://schemas.microsoft.com/office/drawing/2010/main" val="0"/>
+                </a:ext>
+              </a:extLst>
+            </a:blip>
+            <a:stretch>
+              <a:fillRect/>
+            </a:stretch>
+          </p:blipFill>
+          <p:spPr>
+            <a:xfrm>
+              <a:off x="9041671" y="10053754"/>
+              <a:ext cx="3106591" cy="1260016"/>
+            </a:xfrm>
+            <a:prstGeom prst="rect">
+              <a:avLst/>
+            </a:prstGeom>
+          </p:spPr>
+        </p:pic>
+      </p:grpSp>
+      <p:pic>
+        <p:nvPicPr>
+          <p:cNvPr id="55" name="Picture 54">
+            <a:extLst>
+              <a:ext uri="{FF2B5EF4-FFF2-40B4-BE49-F238E27FC236}">
+                <a16:creationId xmlns:a16="http://schemas.microsoft.com/office/drawing/2014/main" id="{63CAA6CC-D0DE-C436-EBF6-FC42E116B933}"/>
+              </a:ext>
+            </a:extLst>
+          </p:cNvPr>
+          <p:cNvPicPr>
+            <a:picLocks noChangeAspect="1"/>
+          </p:cNvPicPr>
+          <p:nvPr/>
+        </p:nvPicPr>
+        <p:blipFill>
+          <a:blip r:embed="rId9">
+            <a:extLst>
+              <a:ext uri="{28A0092B-C50C-407E-A947-70E740481C1C}">
+                <a14:useLocalDpi xmlns:a14="http://schemas.microsoft.com/office/drawing/2010/main" val="0"/>
+              </a:ext>
+            </a:extLst>
+          </a:blip>
+          <a:stretch>
+            <a:fillRect/>
+          </a:stretch>
+        </p:blipFill>
+        <p:spPr>
+          <a:xfrm>
+            <a:off x="2711059" y="15237333"/>
+            <a:ext cx="3383280" cy="612358"/>
+          </a:xfrm>
+          <a:prstGeom prst="rect">
+            <a:avLst/>
+          </a:prstGeom>
+        </p:spPr>
+      </p:pic>
+      <p:pic>
+        <p:nvPicPr>
+          <p:cNvPr id="57" name="Picture 56">
+            <a:extLst>
+              <a:ext uri="{FF2B5EF4-FFF2-40B4-BE49-F238E27FC236}">
+                <a16:creationId xmlns:a16="http://schemas.microsoft.com/office/drawing/2014/main" id="{84FEF396-7E2A-B792-EA42-EECA63C1FEFE}"/>
+              </a:ext>
+            </a:extLst>
+          </p:cNvPr>
+          <p:cNvPicPr>
+            <a:picLocks noChangeAspect="1"/>
+          </p:cNvPicPr>
+          <p:nvPr/>
+        </p:nvPicPr>
+        <p:blipFill>
+          <a:blip r:embed="rId10">
+            <a:extLst>
+              <a:ext uri="{28A0092B-C50C-407E-A947-70E740481C1C}">
+                <a14:useLocalDpi xmlns:a14="http://schemas.microsoft.com/office/drawing/2010/main" val="0"/>
+              </a:ext>
+            </a:extLst>
+          </a:blip>
+          <a:stretch>
+            <a:fillRect/>
+          </a:stretch>
+        </p:blipFill>
+        <p:spPr>
+          <a:xfrm>
+            <a:off x="2116699" y="15936383"/>
+            <a:ext cx="4572000" cy="641195"/>
+          </a:xfrm>
+          <a:prstGeom prst="rect">
+            <a:avLst/>
+          </a:prstGeom>
+        </p:spPr>
+      </p:pic>
+      <p:grpSp>
+        <p:nvGrpSpPr>
+          <p:cNvPr id="61" name="Group 60">
+            <a:extLst>
+              <a:ext uri="{FF2B5EF4-FFF2-40B4-BE49-F238E27FC236}">
+                <a16:creationId xmlns:a16="http://schemas.microsoft.com/office/drawing/2014/main" id="{E79EC4A9-0F88-D131-2562-DD8B20A3EC14}"/>
+              </a:ext>
+            </a:extLst>
+          </p:cNvPr>
+          <p:cNvGrpSpPr/>
+          <p:nvPr/>
+        </p:nvGrpSpPr>
+        <p:grpSpPr>
+          <a:xfrm>
+            <a:off x="8746170" y="6248461"/>
+            <a:ext cx="6752578" cy="1969998"/>
+            <a:chOff x="9041671" y="8083756"/>
+            <a:chExt cx="6752578" cy="1969998"/>
+          </a:xfrm>
+        </p:grpSpPr>
+        <p:pic>
+          <p:nvPicPr>
+            <p:cNvPr id="41" name="Picture 40">
+              <a:extLst>
+                <a:ext uri="{FF2B5EF4-FFF2-40B4-BE49-F238E27FC236}">
+                  <a16:creationId xmlns:a16="http://schemas.microsoft.com/office/drawing/2014/main" id="{D8BDAF07-ACDC-E0CA-44A3-4C00FD7E8AE2}"/>
+                </a:ext>
+              </a:extLst>
+            </p:cNvPr>
+            <p:cNvPicPr>
+              <a:picLocks noChangeAspect="1"/>
+            </p:cNvPicPr>
+            <p:nvPr/>
+          </p:nvPicPr>
+          <p:blipFill>
+            <a:blip r:embed="rId11">
+              <a:extLst>
+                <a:ext uri="{28A0092B-C50C-407E-A947-70E740481C1C}">
+                  <a14:useLocalDpi xmlns:a14="http://schemas.microsoft.com/office/drawing/2010/main" val="0"/>
+                </a:ext>
+              </a:extLst>
+            </a:blip>
+            <a:stretch>
+              <a:fillRect/>
+            </a:stretch>
+          </p:blipFill>
+          <p:spPr>
+            <a:xfrm>
+              <a:off x="9041671" y="8083756"/>
+              <a:ext cx="3108960" cy="1331023"/>
+            </a:xfrm>
+            <a:prstGeom prst="rect">
+              <a:avLst/>
+            </a:prstGeom>
+          </p:spPr>
+        </p:pic>
+        <p:pic>
+          <p:nvPicPr>
+            <p:cNvPr id="39" name="Picture 38">
+              <a:extLst>
+                <a:ext uri="{FF2B5EF4-FFF2-40B4-BE49-F238E27FC236}">
+                  <a16:creationId xmlns:a16="http://schemas.microsoft.com/office/drawing/2014/main" id="{5DC67D21-CBB5-CCA9-5E11-141C04BAB4DC}"/>
+                </a:ext>
+              </a:extLst>
+            </p:cNvPr>
+            <p:cNvPicPr>
+              <a:picLocks noChangeAspect="1"/>
+            </p:cNvPicPr>
+            <p:nvPr/>
+          </p:nvPicPr>
+          <p:blipFill>
+            <a:blip r:embed="rId12">
+              <a:extLst>
+                <a:ext uri="{28A0092B-C50C-407E-A947-70E740481C1C}">
+                  <a14:useLocalDpi xmlns:a14="http://schemas.microsoft.com/office/drawing/2010/main" val="0"/>
+                </a:ext>
+              </a:extLst>
+            </a:blip>
+            <a:stretch>
+              <a:fillRect/>
+            </a:stretch>
+          </p:blipFill>
+          <p:spPr>
+            <a:xfrm>
+              <a:off x="12319529" y="8083756"/>
+              <a:ext cx="3474720" cy="1969998"/>
+            </a:xfrm>
+            <a:prstGeom prst="rect">
+              <a:avLst/>
+            </a:prstGeom>
+          </p:spPr>
+        </p:pic>
+      </p:grpSp>
+      <p:pic>
+        <p:nvPicPr>
+          <p:cNvPr id="63" name="Picture 62">
+            <a:extLst>
+              <a:ext uri="{FF2B5EF4-FFF2-40B4-BE49-F238E27FC236}">
+                <a16:creationId xmlns:a16="http://schemas.microsoft.com/office/drawing/2014/main" id="{21F3D84B-B416-4764-CC5A-799556D9A4EB}"/>
+              </a:ext>
+            </a:extLst>
+          </p:cNvPr>
+          <p:cNvPicPr>
+            <a:picLocks noChangeAspect="1"/>
+          </p:cNvPicPr>
+          <p:nvPr/>
+        </p:nvPicPr>
+        <p:blipFill>
+          <a:blip r:embed="rId13">
+            <a:extLst>
+              <a:ext uri="{28A0092B-C50C-407E-A947-70E740481C1C}">
+                <a14:useLocalDpi xmlns:a14="http://schemas.microsoft.com/office/drawing/2010/main" val="0"/>
+              </a:ext>
+            </a:extLst>
+          </a:blip>
+          <a:stretch>
+            <a:fillRect/>
+          </a:stretch>
+        </p:blipFill>
+        <p:spPr>
+          <a:xfrm>
+            <a:off x="1129543" y="18060280"/>
+            <a:ext cx="3137657" cy="1768498"/>
+          </a:xfrm>
+          <a:prstGeom prst="rect">
+            <a:avLst/>
+          </a:prstGeom>
+        </p:spPr>
+      </p:pic>
+      <p:pic>
+        <p:nvPicPr>
+          <p:cNvPr id="2049" name="Picture 2048">
+            <a:extLst>
+              <a:ext uri="{FF2B5EF4-FFF2-40B4-BE49-F238E27FC236}">
+                <a16:creationId xmlns:a16="http://schemas.microsoft.com/office/drawing/2014/main" id="{E00599AE-D635-5713-3810-095CA0C5BDAA}"/>
+              </a:ext>
+            </a:extLst>
+          </p:cNvPr>
+          <p:cNvPicPr>
+            <a:picLocks noChangeAspect="1"/>
+          </p:cNvPicPr>
+          <p:nvPr/>
+        </p:nvPicPr>
+        <p:blipFill>
+          <a:blip r:embed="rId14">
+            <a:extLst>
+              <a:ext uri="{28A0092B-C50C-407E-A947-70E740481C1C}">
+                <a14:useLocalDpi xmlns:a14="http://schemas.microsoft.com/office/drawing/2010/main" val="0"/>
+              </a:ext>
+            </a:extLst>
+          </a:blip>
+          <a:stretch>
+            <a:fillRect/>
+          </a:stretch>
+        </p:blipFill>
+        <p:spPr>
+          <a:xfrm>
+            <a:off x="17097806" y="12917196"/>
+            <a:ext cx="6619440" cy="7174853"/>
+          </a:xfrm>
+          <a:prstGeom prst="rect">
+            <a:avLst/>
+          </a:prstGeom>
+        </p:spPr>
+      </p:pic>
     </p:spTree>
   </p:cSld>
   <p:clrMapOvr>

</xml_diff>

<commit_message>
updating files as i go
</commit_message>
<xml_diff>
--- a/AT/I-Cat Poster.pptx
+++ b/AT/I-Cat Poster.pptx
@@ -7311,42 +7311,6 @@
           </a:p>
         </p:txBody>
       </p:sp>
-      <p:pic>
-        <p:nvPicPr>
-          <p:cNvPr id="35" name="Picture 34">
-            <a:extLst>
-              <a:ext uri="{FF2B5EF4-FFF2-40B4-BE49-F238E27FC236}">
-                <a16:creationId xmlns:a16="http://schemas.microsoft.com/office/drawing/2014/main" id="{2DF73556-BCD1-760B-7D21-8335D0FF1E99}"/>
-              </a:ext>
-            </a:extLst>
-          </p:cNvPr>
-          <p:cNvPicPr>
-            <a:picLocks noChangeAspect="1"/>
-          </p:cNvPicPr>
-          <p:nvPr/>
-        </p:nvPicPr>
-        <p:blipFill>
-          <a:blip r:embed="rId4">
-            <a:extLst>
-              <a:ext uri="{28A0092B-C50C-407E-A947-70E740481C1C}">
-                <a14:useLocalDpi xmlns:a14="http://schemas.microsoft.com/office/drawing/2010/main" val="0"/>
-              </a:ext>
-            </a:extLst>
-          </a:blip>
-          <a:stretch>
-            <a:fillRect/>
-          </a:stretch>
-        </p:blipFill>
-        <p:spPr>
-          <a:xfrm>
-            <a:off x="19291680" y="6074194"/>
-            <a:ext cx="4935414" cy="5935987"/>
-          </a:xfrm>
-          <a:prstGeom prst="rect">
-            <a:avLst/>
-          </a:prstGeom>
-        </p:spPr>
-      </p:pic>
       <p:sp>
         <p:nvSpPr>
           <p:cNvPr id="36" name="TextBox 35">
@@ -7728,6 +7692,99 @@
           </a:p>
         </p:txBody>
       </p:sp>
+      <p:grpSp>
+        <p:nvGrpSpPr>
+          <p:cNvPr id="60" name="Group 59">
+            <a:extLst>
+              <a:ext uri="{FF2B5EF4-FFF2-40B4-BE49-F238E27FC236}">
+                <a16:creationId xmlns:a16="http://schemas.microsoft.com/office/drawing/2014/main" id="{A662A17A-1ACF-5798-85E5-DC9D6712B66E}"/>
+              </a:ext>
+            </a:extLst>
+          </p:cNvPr>
+          <p:cNvGrpSpPr/>
+          <p:nvPr/>
+        </p:nvGrpSpPr>
+        <p:grpSpPr>
+          <a:xfrm>
+            <a:off x="8755544" y="9177313"/>
+            <a:ext cx="6743204" cy="3529874"/>
+            <a:chOff x="9041671" y="10053754"/>
+            <a:chExt cx="6743204" cy="3529874"/>
+          </a:xfrm>
+        </p:grpSpPr>
+        <p:pic>
+          <p:nvPicPr>
+            <p:cNvPr id="47" name="Picture 46">
+              <a:extLst>
+                <a:ext uri="{FF2B5EF4-FFF2-40B4-BE49-F238E27FC236}">
+                  <a16:creationId xmlns:a16="http://schemas.microsoft.com/office/drawing/2014/main" id="{50505D91-E574-2F7B-3E0E-5977FACE2CD0}"/>
+                </a:ext>
+              </a:extLst>
+            </p:cNvPr>
+            <p:cNvPicPr>
+              <a:picLocks noChangeAspect="1"/>
+            </p:cNvPicPr>
+            <p:nvPr/>
+          </p:nvPicPr>
+          <p:blipFill>
+            <a:blip r:embed="rId4">
+              <a:extLst>
+                <a:ext uri="{28A0092B-C50C-407E-A947-70E740481C1C}">
+                  <a14:useLocalDpi xmlns:a14="http://schemas.microsoft.com/office/drawing/2010/main" val="0"/>
+                </a:ext>
+              </a:extLst>
+            </a:blip>
+            <a:stretch>
+              <a:fillRect/>
+            </a:stretch>
+          </p:blipFill>
+          <p:spPr>
+            <a:xfrm>
+              <a:off x="12310155" y="10053754"/>
+              <a:ext cx="3474720" cy="3529874"/>
+            </a:xfrm>
+            <a:prstGeom prst="rect">
+              <a:avLst/>
+            </a:prstGeom>
+          </p:spPr>
+        </p:pic>
+        <p:pic>
+          <p:nvPicPr>
+            <p:cNvPr id="53" name="Picture 52">
+              <a:extLst>
+                <a:ext uri="{FF2B5EF4-FFF2-40B4-BE49-F238E27FC236}">
+                  <a16:creationId xmlns:a16="http://schemas.microsoft.com/office/drawing/2014/main" id="{B4D42461-26BA-4A57-EF64-9D88FA5AC051}"/>
+                </a:ext>
+              </a:extLst>
+            </p:cNvPr>
+            <p:cNvPicPr>
+              <a:picLocks noChangeAspect="1"/>
+            </p:cNvPicPr>
+            <p:nvPr/>
+          </p:nvPicPr>
+          <p:blipFill>
+            <a:blip r:embed="rId5">
+              <a:extLst>
+                <a:ext uri="{28A0092B-C50C-407E-A947-70E740481C1C}">
+                  <a14:useLocalDpi xmlns:a14="http://schemas.microsoft.com/office/drawing/2010/main" val="0"/>
+                </a:ext>
+              </a:extLst>
+            </a:blip>
+            <a:stretch>
+              <a:fillRect/>
+            </a:stretch>
+          </p:blipFill>
+          <p:spPr>
+            <a:xfrm>
+              <a:off x="9041671" y="10053754"/>
+              <a:ext cx="3106591" cy="1260016"/>
+            </a:xfrm>
+            <a:prstGeom prst="rect">
+              <a:avLst/>
+            </a:prstGeom>
+          </p:spPr>
+        </p:pic>
+      </p:grpSp>
       <p:sp>
         <p:nvSpPr>
           <p:cNvPr id="37" name="Rectangle 10">
@@ -8267,99 +8324,6 @@
       </p:sp>
       <p:grpSp>
         <p:nvGrpSpPr>
-          <p:cNvPr id="60" name="Group 59">
-            <a:extLst>
-              <a:ext uri="{FF2B5EF4-FFF2-40B4-BE49-F238E27FC236}">
-                <a16:creationId xmlns:a16="http://schemas.microsoft.com/office/drawing/2014/main" id="{A662A17A-1ACF-5798-85E5-DC9D6712B66E}"/>
-              </a:ext>
-            </a:extLst>
-          </p:cNvPr>
-          <p:cNvGrpSpPr/>
-          <p:nvPr/>
-        </p:nvGrpSpPr>
-        <p:grpSpPr>
-          <a:xfrm>
-            <a:off x="8755544" y="9177313"/>
-            <a:ext cx="6743204" cy="3529874"/>
-            <a:chOff x="9041671" y="10053754"/>
-            <a:chExt cx="6743204" cy="3529874"/>
-          </a:xfrm>
-        </p:grpSpPr>
-        <p:pic>
-          <p:nvPicPr>
-            <p:cNvPr id="47" name="Picture 46">
-              <a:extLst>
-                <a:ext uri="{FF2B5EF4-FFF2-40B4-BE49-F238E27FC236}">
-                  <a16:creationId xmlns:a16="http://schemas.microsoft.com/office/drawing/2014/main" id="{50505D91-E574-2F7B-3E0E-5977FACE2CD0}"/>
-                </a:ext>
-              </a:extLst>
-            </p:cNvPr>
-            <p:cNvPicPr>
-              <a:picLocks noChangeAspect="1"/>
-            </p:cNvPicPr>
-            <p:nvPr/>
-          </p:nvPicPr>
-          <p:blipFill>
-            <a:blip r:embed="rId5">
-              <a:extLst>
-                <a:ext uri="{28A0092B-C50C-407E-A947-70E740481C1C}">
-                  <a14:useLocalDpi xmlns:a14="http://schemas.microsoft.com/office/drawing/2010/main" val="0"/>
-                </a:ext>
-              </a:extLst>
-            </a:blip>
-            <a:stretch>
-              <a:fillRect/>
-            </a:stretch>
-          </p:blipFill>
-          <p:spPr>
-            <a:xfrm>
-              <a:off x="12310155" y="10053754"/>
-              <a:ext cx="3474720" cy="3529874"/>
-            </a:xfrm>
-            <a:prstGeom prst="rect">
-              <a:avLst/>
-            </a:prstGeom>
-          </p:spPr>
-        </p:pic>
-        <p:pic>
-          <p:nvPicPr>
-            <p:cNvPr id="53" name="Picture 52">
-              <a:extLst>
-                <a:ext uri="{FF2B5EF4-FFF2-40B4-BE49-F238E27FC236}">
-                  <a16:creationId xmlns:a16="http://schemas.microsoft.com/office/drawing/2014/main" id="{B4D42461-26BA-4A57-EF64-9D88FA5AC051}"/>
-                </a:ext>
-              </a:extLst>
-            </p:cNvPr>
-            <p:cNvPicPr>
-              <a:picLocks noChangeAspect="1"/>
-            </p:cNvPicPr>
-            <p:nvPr/>
-          </p:nvPicPr>
-          <p:blipFill>
-            <a:blip r:embed="rId6">
-              <a:extLst>
-                <a:ext uri="{28A0092B-C50C-407E-A947-70E740481C1C}">
-                  <a14:useLocalDpi xmlns:a14="http://schemas.microsoft.com/office/drawing/2010/main" val="0"/>
-                </a:ext>
-              </a:extLst>
-            </a:blip>
-            <a:stretch>
-              <a:fillRect/>
-            </a:stretch>
-          </p:blipFill>
-          <p:spPr>
-            <a:xfrm>
-              <a:off x="9041671" y="10053754"/>
-              <a:ext cx="3106591" cy="1260016"/>
-            </a:xfrm>
-            <a:prstGeom prst="rect">
-              <a:avLst/>
-            </a:prstGeom>
-          </p:spPr>
-        </p:pic>
-      </p:grpSp>
-      <p:grpSp>
-        <p:nvGrpSpPr>
           <p:cNvPr id="61" name="Group 60">
             <a:extLst>
               <a:ext uri="{FF2B5EF4-FFF2-40B4-BE49-F238E27FC236}">
@@ -8393,7 +8357,7 @@
             <p:nvPr/>
           </p:nvPicPr>
           <p:blipFill>
-            <a:blip r:embed="rId7">
+            <a:blip r:embed="rId6">
               <a:extLst>
                 <a:ext uri="{28A0092B-C50C-407E-A947-70E740481C1C}">
                   <a14:useLocalDpi xmlns:a14="http://schemas.microsoft.com/office/drawing/2010/main" val="0"/>
@@ -8429,7 +8393,7 @@
             <p:nvPr/>
           </p:nvPicPr>
           <p:blipFill>
-            <a:blip r:embed="rId8">
+            <a:blip r:embed="rId7">
               <a:extLst>
                 <a:ext uri="{28A0092B-C50C-407E-A947-70E740481C1C}">
                   <a14:useLocalDpi xmlns:a14="http://schemas.microsoft.com/office/drawing/2010/main" val="0"/>
@@ -8451,6 +8415,42 @@
           </p:spPr>
         </p:pic>
       </p:grpSp>
+      <p:pic>
+        <p:nvPicPr>
+          <p:cNvPr id="63" name="Picture 62">
+            <a:extLst>
+              <a:ext uri="{FF2B5EF4-FFF2-40B4-BE49-F238E27FC236}">
+                <a16:creationId xmlns:a16="http://schemas.microsoft.com/office/drawing/2014/main" id="{21F3D84B-B416-4764-CC5A-799556D9A4EB}"/>
+              </a:ext>
+            </a:extLst>
+          </p:cNvPr>
+          <p:cNvPicPr>
+            <a:picLocks noChangeAspect="1"/>
+          </p:cNvPicPr>
+          <p:nvPr/>
+        </p:nvPicPr>
+        <p:blipFill>
+          <a:blip r:embed="rId8">
+            <a:extLst>
+              <a:ext uri="{28A0092B-C50C-407E-A947-70E740481C1C}">
+                <a14:useLocalDpi xmlns:a14="http://schemas.microsoft.com/office/drawing/2010/main" val="0"/>
+              </a:ext>
+            </a:extLst>
+          </a:blip>
+          <a:stretch>
+            <a:fillRect/>
+          </a:stretch>
+        </p:blipFill>
+        <p:spPr>
+          <a:xfrm>
+            <a:off x="1129638" y="18338253"/>
+            <a:ext cx="3655260" cy="2060238"/>
+          </a:xfrm>
+          <a:prstGeom prst="rect">
+            <a:avLst/>
+          </a:prstGeom>
+        </p:spPr>
+      </p:pic>
       <p:pic>
         <p:nvPicPr>
           <p:cNvPr id="55" name="Picture 54">
@@ -8523,78 +8523,6 @@
           </a:prstGeom>
         </p:spPr>
       </p:pic>
-      <p:pic>
-        <p:nvPicPr>
-          <p:cNvPr id="63" name="Picture 62">
-            <a:extLst>
-              <a:ext uri="{FF2B5EF4-FFF2-40B4-BE49-F238E27FC236}">
-                <a16:creationId xmlns:a16="http://schemas.microsoft.com/office/drawing/2014/main" id="{21F3D84B-B416-4764-CC5A-799556D9A4EB}"/>
-              </a:ext>
-            </a:extLst>
-          </p:cNvPr>
-          <p:cNvPicPr>
-            <a:picLocks noChangeAspect="1"/>
-          </p:cNvPicPr>
-          <p:nvPr/>
-        </p:nvPicPr>
-        <p:blipFill>
-          <a:blip r:embed="rId11">
-            <a:extLst>
-              <a:ext uri="{28A0092B-C50C-407E-A947-70E740481C1C}">
-                <a14:useLocalDpi xmlns:a14="http://schemas.microsoft.com/office/drawing/2010/main" val="0"/>
-              </a:ext>
-            </a:extLst>
-          </a:blip>
-          <a:stretch>
-            <a:fillRect/>
-          </a:stretch>
-        </p:blipFill>
-        <p:spPr>
-          <a:xfrm>
-            <a:off x="1129638" y="18338253"/>
-            <a:ext cx="3655260" cy="2060238"/>
-          </a:xfrm>
-          <a:prstGeom prst="rect">
-            <a:avLst/>
-          </a:prstGeom>
-        </p:spPr>
-      </p:pic>
-      <p:pic>
-        <p:nvPicPr>
-          <p:cNvPr id="2049" name="Picture 2048">
-            <a:extLst>
-              <a:ext uri="{FF2B5EF4-FFF2-40B4-BE49-F238E27FC236}">
-                <a16:creationId xmlns:a16="http://schemas.microsoft.com/office/drawing/2014/main" id="{E00599AE-D635-5713-3810-095CA0C5BDAA}"/>
-              </a:ext>
-            </a:extLst>
-          </p:cNvPr>
-          <p:cNvPicPr>
-            <a:picLocks noChangeAspect="1"/>
-          </p:cNvPicPr>
-          <p:nvPr/>
-        </p:nvPicPr>
-        <p:blipFill>
-          <a:blip r:embed="rId12">
-            <a:extLst>
-              <a:ext uri="{28A0092B-C50C-407E-A947-70E740481C1C}">
-                <a14:useLocalDpi xmlns:a14="http://schemas.microsoft.com/office/drawing/2010/main" val="0"/>
-              </a:ext>
-            </a:extLst>
-          </a:blip>
-          <a:stretch>
-            <a:fillRect/>
-          </a:stretch>
-        </p:blipFill>
-        <p:spPr>
-          <a:xfrm>
-            <a:off x="16403385" y="12322432"/>
-            <a:ext cx="7823709" cy="8480168"/>
-          </a:xfrm>
-          <a:prstGeom prst="rect">
-            <a:avLst/>
-          </a:prstGeom>
-        </p:spPr>
-      </p:pic>
       <p:sp>
         <p:nvSpPr>
           <p:cNvPr id="2054" name="TextBox 2053">
@@ -9015,7 +8943,7 @@
           <p:nvPr/>
         </p:nvPicPr>
         <p:blipFill>
-          <a:blip r:embed="rId13">
+          <a:blip r:embed="rId11">
             <a:extLst>
               <a:ext uri="{28A0092B-C50C-407E-A947-70E740481C1C}">
                 <a14:useLocalDpi xmlns:a14="http://schemas.microsoft.com/office/drawing/2010/main" val="0"/>
@@ -9116,6 +9044,78 @@
           </a:p>
         </p:txBody>
       </p:sp>
+      <p:pic>
+        <p:nvPicPr>
+          <p:cNvPr id="2062" name="Picture 2061">
+            <a:extLst>
+              <a:ext uri="{FF2B5EF4-FFF2-40B4-BE49-F238E27FC236}">
+                <a16:creationId xmlns:a16="http://schemas.microsoft.com/office/drawing/2014/main" id="{BF5F4C9B-2239-9822-9A6C-E99DDF205E5A}"/>
+              </a:ext>
+            </a:extLst>
+          </p:cNvPr>
+          <p:cNvPicPr>
+            <a:picLocks noChangeAspect="1"/>
+          </p:cNvPicPr>
+          <p:nvPr/>
+        </p:nvPicPr>
+        <p:blipFill>
+          <a:blip r:embed="rId12">
+            <a:extLst>
+              <a:ext uri="{28A0092B-C50C-407E-A947-70E740481C1C}">
+                <a14:useLocalDpi xmlns:a14="http://schemas.microsoft.com/office/drawing/2010/main" val="0"/>
+              </a:ext>
+            </a:extLst>
+          </a:blip>
+          <a:stretch>
+            <a:fillRect/>
+          </a:stretch>
+        </p:blipFill>
+        <p:spPr>
+          <a:xfrm>
+            <a:off x="19466035" y="6249485"/>
+            <a:ext cx="4826844" cy="5854408"/>
+          </a:xfrm>
+          <a:prstGeom prst="rect">
+            <a:avLst/>
+          </a:prstGeom>
+        </p:spPr>
+      </p:pic>
+      <p:pic>
+        <p:nvPicPr>
+          <p:cNvPr id="2064" name="Picture 2063">
+            <a:extLst>
+              <a:ext uri="{FF2B5EF4-FFF2-40B4-BE49-F238E27FC236}">
+                <a16:creationId xmlns:a16="http://schemas.microsoft.com/office/drawing/2014/main" id="{46463C44-30E2-4529-CA50-2F6100785FA2}"/>
+              </a:ext>
+            </a:extLst>
+          </p:cNvPr>
+          <p:cNvPicPr>
+            <a:picLocks noChangeAspect="1"/>
+          </p:cNvPicPr>
+          <p:nvPr/>
+        </p:nvPicPr>
+        <p:blipFill>
+          <a:blip r:embed="rId13">
+            <a:extLst>
+              <a:ext uri="{28A0092B-C50C-407E-A947-70E740481C1C}">
+                <a14:useLocalDpi xmlns:a14="http://schemas.microsoft.com/office/drawing/2010/main" val="0"/>
+              </a:ext>
+            </a:extLst>
+          </a:blip>
+          <a:stretch>
+            <a:fillRect/>
+          </a:stretch>
+        </p:blipFill>
+        <p:spPr>
+          <a:xfrm>
+            <a:off x="16337599" y="12247837"/>
+            <a:ext cx="7955280" cy="8659481"/>
+          </a:xfrm>
+          <a:prstGeom prst="rect">
+            <a:avLst/>
+          </a:prstGeom>
+        </p:spPr>
+      </p:pic>
     </p:spTree>
   </p:cSld>
   <p:clrMapOvr>

</xml_diff>